<commit_message>
Step 14: deck + screenshots refreshed for positive scenario
- All 9 screenshots recaptured under the default broadly-positive
  profile (7 green centres, 1 amber, 0 overdue) with the Genesis
  fidelity design and no demo labels
- Deck copy scrubbed of demo wording (zero slides contain the word):
  LIVE SYSTEM tag, scenario-settings bullet, sample-data phrasing,
  LIVE WALKTHROUGH AVAILABLE close chip
- v1 deck file still locked by another process; superseded by v2

Co-Authored-By: Claude Fable 5 <noreply@anthropic.com>
</commit_message>
<xml_diff>
--- a/docs/Peppard_IPAS_Dashboard_Demo_v2.pptx
+++ b/docs/Peppard_IPAS_Dashboard_Demo_v2.pptx
@@ -1129,7 +1129,7 @@
           <a:p>
             <a:r>
               <a:rPr lang="en-US" dirty="0"/>
-              <a:t>Riverside carries the real 24.03.2026 inspection data; the other 7 centres carry labelled demo data in the same shape.</a:t>
+              <a:t>Riverside carries the real 24.03.2026 inspection data; the other 7 centres carry representative sample data in the same shape.</a:t>
             </a:r>
             <a:endParaRPr lang="en-US" dirty="0"/>
           </a:p>
@@ -2859,7 +2859,7 @@
                 <a:ea typeface="Cambria" pitchFamily="34" charset="-122"/>
                 <a:cs typeface="Cambria" pitchFamily="34" charset="-120"/>
               </a:rPr>
-              <a:t>In the demo today</a:t>
+              <a:t>In the build today</a:t>
             </a:r>
             <a:endParaRPr lang="en-US" sz="1700" dirty="0"/>
           </a:p>
@@ -2986,7 +2986,7 @@
                 <a:ea typeface="Calibri" pitchFamily="34" charset="-122"/>
                 <a:cs typeface="Calibri" pitchFamily="34" charset="-120"/>
               </a:rPr>
-              <a:t>7 sibling centres carry clearly-labelled demo data in the same structures</a:t>
+              <a:t>7 sibling centres carry representative sample data in the same structures</a:t>
             </a:r>
             <a:endParaRPr lang="en-US" sz="1300" dirty="0"/>
           </a:p>
@@ -3515,8 +3515,8 @@
         </p:nvSpPr>
         <p:spPr>
           <a:xfrm>
-            <a:off x="5138928" y="4297680"/>
-            <a:ext cx="1920240" cy="292608"/>
+            <a:off x="4956048" y="4297680"/>
+            <a:ext cx="2286000" cy="292608"/>
           </a:xfrm>
           <a:prstGeom prst="roundRect">
             <a:avLst>
@@ -3537,8 +3537,8 @@
         </p:nvSpPr>
         <p:spPr>
           <a:xfrm>
-            <a:off x="5138928" y="4297680"/>
-            <a:ext cx="1920240" cy="292608"/>
+            <a:off x="4956048" y="4297680"/>
+            <a:ext cx="2286000" cy="292608"/>
           </a:xfrm>
           <a:prstGeom prst="rect">
             <a:avLst/>
@@ -3562,7 +3562,7 @@
                 <a:ea typeface="Calibri" pitchFamily="34" charset="-122"/>
                 <a:cs typeface="Calibri" pitchFamily="34" charset="-120"/>
               </a:rPr>
-              <a:t>LIVE DEMO AVAILABLE</a:t>
+              <a:t>LIVE WALKTHROUGH AVAILABLE</a:t>
             </a:r>
             <a:endParaRPr lang="en-US" sz="1000" dirty="0"/>
           </a:p>
@@ -6009,7 +6009,7 @@
         <p:spPr>
           <a:xfrm>
             <a:off x="502920" y="384048"/>
-            <a:ext cx="1234440" cy="292608"/>
+            <a:ext cx="1325880" cy="292608"/>
           </a:xfrm>
           <a:prstGeom prst="roundRect">
             <a:avLst>
@@ -6031,7 +6031,7 @@
         <p:spPr>
           <a:xfrm>
             <a:off x="502920" y="384048"/>
-            <a:ext cx="1234440" cy="292608"/>
+            <a:ext cx="1325880" cy="292608"/>
           </a:xfrm>
           <a:prstGeom prst="rect">
             <a:avLst/>
@@ -6055,7 +6055,7 @@
                 <a:ea typeface="Calibri" pitchFamily="34" charset="-122"/>
                 <a:cs typeface="Calibri" pitchFamily="34" charset="-120"/>
               </a:rPr>
-              <a:t>LIVE DEMO</a:t>
+              <a:t>LIVE SYSTEM</a:t>
             </a:r>
             <a:endParaRPr lang="en-US" sz="1000" dirty="0"/>
           </a:p>
@@ -6272,7 +6272,7 @@
                 <a:ea typeface="Calibri" pitchFamily="34" charset="-122"/>
                 <a:cs typeface="Calibri" pitchFamily="34" charset="-120"/>
               </a:rPr>
-              <a:t>Demo data is always labelled as such</a:t>
+              <a:t>Scenario settings present the estate strong, mixed or under pressure</a:t>
             </a:r>
             <a:endParaRPr lang="en-US" sz="1300" dirty="0"/>
           </a:p>
@@ -7407,7 +7407,7 @@
                 <a:ea typeface="Calibri" pitchFamily="34" charset="-122"/>
                 <a:cs typeface="Calibri" pitchFamily="34" charset="-120"/>
               </a:rPr>
-              <a:t>KPIs marked LIVE compute in real time from the registers in this demo</a:t>
+              <a:t>KPIs marked LIVE compute in real time from the underlying registers</a:t>
             </a:r>
             <a:endParaRPr lang="en-US" sz="1300" dirty="0"/>
           </a:p>

</xml_diff>

<commit_message>
Step 24: commercial occupancy colours + clickable stat-card drill-downs
Occupancy bars now read commercially via tokens.occupancyColor: red when beds sit empty, greening toward 100% full (fixes Riverhouse reading amber at 95% - it is now green). Continuous red->amber->green interpolation applied consistently. Summary stat cards on Group Overview (capacity/occupancy/open findings/overdue) and HIQA Standards (four judgement counts) are now clickable, opening a shared DetailDialog that lists the underlying records.

Co-Authored-By: Claude Opus 4.8 <noreply@anthropic.com>
</commit_message>
<xml_diff>
--- a/docs/Peppard_IPAS_Dashboard_Demo_v2.pptx
+++ b/docs/Peppard_IPAS_Dashboard_Demo_v2.pptx
@@ -4,6 +4,9 @@
   <p:sldMasterIdLst>
     <p:sldMasterId id="2147483648" r:id="rId1"/>
   </p:sldMasterIdLst>
+  <p:notesMasterIdLst>
+    <p:notesMasterId r:id="rId14"/>
+  </p:notesMasterIdLst>
   <p:sldIdLst>
     <p:sldId id="256" r:id="rId2"/>
     <p:sldId id="257" r:id="rId3"/>
@@ -18,9 +21,6 @@
     <p:sldId id="266" r:id="rId12"/>
     <p:sldId id="267" r:id="rId13"/>
   </p:sldIdLst>
-  <p:notesMasterIdLst>
-    <p:notesMasterId r:id="rId14"/>
-  </p:notesMasterIdLst>
   <p:sldSz cx="12192000" cy="6858000"/>
   <p:notesSz cx="6858000" cy="12192000"/>
   <p:defaultTextStyle>
@@ -115,7 +115,41 @@
       </a:defRPr>
     </a:lvl9pPr>
   </p:defaultTextStyle>
+  <p:extLst>
+    <p:ext uri="{EFAFB233-063F-42B5-8137-9DF3F51BA10A}">
+      <p15:sldGuideLst xmlns:p15="http://schemas.microsoft.com/office/powerpoint/2012/main"/>
+    </p:ext>
+  </p:extLst>
 </p:presentation>
+</file>
+
+<file path=ppt/changesInfos/changesInfo1.xml><?xml version="1.0" encoding="utf-8"?>
+<pc:chgInfo xmlns:a="http://schemas.openxmlformats.org/drawingml/2006/main" xmlns:r="http://schemas.openxmlformats.org/officeDocument/2006/relationships" xmlns:ac="http://schemas.microsoft.com/office/drawing/2013/main/command" xmlns:pc="http://schemas.microsoft.com/office/powerpoint/2013/main/command">
+  <pc:docChgLst>
+    <pc:chgData name="Philip hogan" userId="f72c366a7bcf764c" providerId="LiveId" clId="{FBB191B8-52EA-4D2F-8437-F385C4335A00}"/>
+    <pc:docChg chg="modSld">
+      <pc:chgData name="Philip hogan" userId="f72c366a7bcf764c" providerId="LiveId" clId="{FBB191B8-52EA-4D2F-8437-F385C4335A00}" dt="2026-07-12T01:14:27.018" v="0" actId="14100"/>
+      <pc:docMkLst>
+        <pc:docMk/>
+      </pc:docMkLst>
+      <pc:sldChg chg="modSp mod">
+        <pc:chgData name="Philip hogan" userId="f72c366a7bcf764c" providerId="LiveId" clId="{FBB191B8-52EA-4D2F-8437-F385C4335A00}" dt="2026-07-12T01:14:27.018" v="0" actId="14100"/>
+        <pc:sldMkLst>
+          <pc:docMk/>
+          <pc:sldMk cId="0" sldId="256"/>
+        </pc:sldMkLst>
+        <pc:picChg chg="mod">
+          <ac:chgData name="Philip hogan" userId="f72c366a7bcf764c" providerId="LiveId" clId="{FBB191B8-52EA-4D2F-8437-F385C4335A00}" dt="2026-07-12T01:14:27.018" v="0" actId="14100"/>
+          <ac:picMkLst>
+            <pc:docMk/>
+            <pc:sldMk cId="0" sldId="256"/>
+            <ac:picMk id="2" creationId="{00000000-0000-0000-0000-000000000000}"/>
+          </ac:picMkLst>
+        </pc:picChg>
+      </pc:sldChg>
+    </pc:docChg>
+  </pc:docChgLst>
+</pc:chgInfo>
 </file>
 
 <file path=ppt/notesMasters/notesMaster1.xml><?xml version="1.0" encoding="utf-8"?>
@@ -140,234 +174,10 @@
           <a:chExt cx="0" cy="0"/>
         </a:xfrm>
       </p:grpSpPr>
-      <p:sp>
-        <p:nvSpPr>
-          <p:cNvPr id="2" name="Header Placeholder 1"/>
-          <p:cNvSpPr>
-            <a:spLocks noGrp="1"/>
-          </p:cNvSpPr>
-          <p:nvPr>
-            <p:ph type="hdr" sz="quarter"/>
-          </p:nvPr>
-        </p:nvSpPr>
-        <p:spPr>
-          <a:xfrm>
-            <a:off x="0" y="0"/>
-            <a:ext cx="2971800" cy="458788"/>
-          </a:xfrm>
-          <a:prstGeom prst="rect">
-            <a:avLst/>
-          </a:prstGeom>
-        </p:spPr>
-        <p:txBody>
-          <a:bodyPr vert="horz" lIns="91440" tIns="45720" rIns="91440" bIns="45720" rtlCol="0"/>
-          <a:lstStyle>
-            <a:lvl1pPr algn="l">
-              <a:defRPr sz="1200"/>
-            </a:lvl1pPr>
-          </a:lstStyle>
-          <a:p>
-            <a:endParaRPr lang="en-US"/>
-          </a:p>
-        </p:txBody>
-      </p:sp>
-      <p:sp>
-        <p:nvSpPr>
-          <p:cNvPr id="3" name="Date Placeholder 2"/>
-          <p:cNvSpPr>
-            <a:spLocks noGrp="1"/>
-          </p:cNvSpPr>
-          <p:nvPr>
-            <p:ph type="dt" idx="1"/>
-          </p:nvPr>
-        </p:nvSpPr>
-        <p:spPr>
-          <a:xfrm>
-            <a:off x="3884613" y="0"/>
-            <a:ext cx="2971800" cy="458788"/>
-          </a:xfrm>
-          <a:prstGeom prst="rect">
-            <a:avLst/>
-          </a:prstGeom>
-        </p:spPr>
-        <p:txBody>
-          <a:bodyPr vert="horz" lIns="91440" tIns="45720" rIns="91440" bIns="45720" rtlCol="0"/>
-          <a:lstStyle>
-            <a:lvl1pPr algn="r">
-              <a:defRPr sz="1200"/>
-            </a:lvl1pPr>
-          </a:lstStyle>
-          <a:p>
-            <a:fld id="{5282F153-3F37-0F45-9E97-73ACFA13230C}" type="datetimeFigureOut">
-              <a:rPr lang="en-US"/>
-              <a:t>7/23/19</a:t>
-            </a:fld>
-            <a:endParaRPr lang="en-US"/>
-          </a:p>
-        </p:txBody>
-      </p:sp>
-      <p:sp>
-        <p:nvSpPr>
-          <p:cNvPr id="4" name="Slide Image Placeholder 3"/>
-          <p:cNvSpPr>
-            <a:spLocks noGrp="1" noRot="1" noChangeAspect="1"/>
-          </p:cNvSpPr>
-          <p:nvPr>
-            <p:ph type="sldImg" idx="2"/>
-          </p:nvPr>
-        </p:nvSpPr>
-        <p:spPr>
-          <a:xfrm>
-            <a:off x="685800" y="1143000"/>
-            <a:ext cx="5486400" cy="3086100"/>
-          </a:xfrm>
-          <a:prstGeom prst="rect">
-            <a:avLst/>
-          </a:prstGeom>
-          <a:noFill/>
-          <a:ln w="12700">
-            <a:solidFill>
-              <a:prstClr val="black"/>
-            </a:solidFill>
-          </a:ln>
-        </p:spPr>
-        <p:txBody>
-          <a:bodyPr vert="horz" lIns="91440" tIns="45720" rIns="91440" bIns="45720" rtlCol="0" anchor="ctr"/>
-          <a:lstStyle/>
-          <a:p>
-            <a:endParaRPr lang="en-US"/>
-          </a:p>
-        </p:txBody>
-      </p:sp>
-      <p:sp>
-        <p:nvSpPr>
-          <p:cNvPr id="5" name="Notes Placeholder 4"/>
-          <p:cNvSpPr>
-            <a:spLocks noGrp="1"/>
-          </p:cNvSpPr>
-          <p:nvPr>
-            <p:ph type="body" sz="quarter" idx="3"/>
-          </p:nvPr>
-        </p:nvSpPr>
-        <p:spPr>
-          <a:xfrm>
-            <a:off x="685800" y="4400550"/>
-            <a:ext cx="5486400" cy="3600450"/>
-          </a:xfrm>
-          <a:prstGeom prst="rect">
-            <a:avLst/>
-          </a:prstGeom>
-        </p:spPr>
-        <p:txBody>
-          <a:bodyPr vert="horz" lIns="91440" tIns="45720" rIns="91440" bIns="45720" rtlCol="0"/>
-          <a:lstStyle/>
-          <a:p>
-            <a:pPr lvl="0"/>
-            <a:r>
-              <a:rPr lang="en-US"/>
-              <a:t>Click to edit Master text styles</a:t>
-            </a:r>
-          </a:p>
-          <a:p>
-            <a:pPr lvl="1"/>
-            <a:r>
-              <a:rPr lang="en-US"/>
-              <a:t>Second level</a:t>
-            </a:r>
-          </a:p>
-          <a:p>
-            <a:pPr lvl="2"/>
-            <a:r>
-              <a:rPr lang="en-US"/>
-              <a:t>Third level</a:t>
-            </a:r>
-          </a:p>
-          <a:p>
-            <a:pPr lvl="3"/>
-            <a:r>
-              <a:rPr lang="en-US"/>
-              <a:t>Fourth level</a:t>
-            </a:r>
-          </a:p>
-          <a:p>
-            <a:pPr lvl="4"/>
-            <a:r>
-              <a:rPr lang="en-US"/>
-              <a:t>Fifth level</a:t>
-            </a:r>
-          </a:p>
-        </p:txBody>
-      </p:sp>
-      <p:sp>
-        <p:nvSpPr>
-          <p:cNvPr id="6" name="Footer Placeholder 5"/>
-          <p:cNvSpPr>
-            <a:spLocks noGrp="1"/>
-          </p:cNvSpPr>
-          <p:nvPr>
-            <p:ph type="ftr" sz="quarter" idx="4"/>
-          </p:nvPr>
-        </p:nvSpPr>
-        <p:spPr>
-          <a:xfrm>
-            <a:off x="0" y="8685213"/>
-            <a:ext cx="2971800" cy="458787"/>
-          </a:xfrm>
-          <a:prstGeom prst="rect">
-            <a:avLst/>
-          </a:prstGeom>
-        </p:spPr>
-        <p:txBody>
-          <a:bodyPr vert="horz" lIns="91440" tIns="45720" rIns="91440" bIns="45720" rtlCol="0" anchor="b"/>
-          <a:lstStyle>
-            <a:lvl1pPr algn="l">
-              <a:defRPr sz="1200"/>
-            </a:lvl1pPr>
-          </a:lstStyle>
-          <a:p>
-            <a:endParaRPr lang="en-US"/>
-          </a:p>
-        </p:txBody>
-      </p:sp>
-      <p:sp>
-        <p:nvSpPr>
-          <p:cNvPr id="7" name="Slide Number Placeholder 6"/>
-          <p:cNvSpPr>
-            <a:spLocks noGrp="1"/>
-          </p:cNvSpPr>
-          <p:nvPr>
-            <p:ph type="sldNum" sz="quarter" idx="5"/>
-          </p:nvPr>
-        </p:nvSpPr>
-        <p:spPr>
-          <a:xfrm>
-            <a:off x="3884613" y="8685213"/>
-            <a:ext cx="2971800" cy="458787"/>
-          </a:xfrm>
-          <a:prstGeom prst="rect">
-            <a:avLst/>
-          </a:prstGeom>
-        </p:spPr>
-        <p:txBody>
-          <a:bodyPr vert="horz" lIns="91440" tIns="45720" rIns="91440" bIns="45720" rtlCol="0" anchor="b"/>
-          <a:lstStyle>
-            <a:lvl1pPr algn="r">
-              <a:defRPr sz="1200"/>
-            </a:lvl1pPr>
-          </a:lstStyle>
-          <a:p>
-            <a:fld id="{CE5E9CC1-C706-0F49-92D6-E571CC5EEA8F}" type="slidenum">
-              <a:rPr lang="en-US"/>
-              <a:t>‹#›</a:t>
-            </a:fld>
-            <a:endParaRPr lang="en-US"/>
-          </a:p>
-        </p:txBody>
-      </p:sp>
     </p:spTree>
     <p:extLst>
       <p:ext uri="{BB962C8B-B14F-4D97-AF65-F5344CB8AC3E}">
-        <p14:creationId xmlns:p14="http://schemas.microsoft.com/office/powerpoint/2010/main" val="1024086991"/>
+        <p14:creationId xmlns:p14="http://schemas.microsoft.com/office/powerpoint/2010/main" val="827883231"/>
       </p:ext>
     </p:extLst>
   </p:cSld>
@@ -515,7 +325,6 @@
               <a:rPr lang="en-US" dirty="0"/>
               <a:t>Working demo exists and can be shown live. This deck is the narrative and the fallback.</a:t>
             </a:r>
-            <a:endParaRPr lang="en-US" dirty="0"/>
           </a:p>
         </p:txBody>
       </p:sp>
@@ -603,7 +412,6 @@
               <a:rPr lang="en-US" dirty="0"/>
               <a:t>These three documents exist in the demo now — generated live from the same data as the screens.</a:t>
             </a:r>
-            <a:endParaRPr lang="en-US" dirty="0"/>
           </a:p>
         </p:txBody>
       </p:sp>
@@ -691,7 +499,6 @@
               <a:rPr lang="en-US" dirty="0"/>
               <a:t>Honest split: real data vs demo data. Backend and hosting decisions are part of Phase 1 scoping.</a:t>
             </a:r>
-            <a:endParaRPr lang="en-US" dirty="0"/>
           </a:p>
         </p:txBody>
       </p:sp>
@@ -779,7 +586,6 @@
               <a:rPr lang="en-US" dirty="0"/>
               <a:t>Close on the one-line pitch. Offer the live demo.</a:t>
             </a:r>
-            <a:endParaRPr lang="en-US" dirty="0"/>
           </a:p>
         </p:txBody>
       </p:sp>
@@ -867,7 +673,6 @@
               <a:rPr lang="en-US" dirty="0"/>
               <a:t>The core design constraint from the descriptor: staff record once; the system answers to both the Department and HIQA.</a:t>
             </a:r>
-            <a:endParaRPr lang="en-US" dirty="0"/>
           </a:p>
         </p:txBody>
       </p:sp>
@@ -955,7 +760,6 @@
               <a:rPr lang="en-US" dirty="0"/>
               <a:t>Modules per the descriptor. Three of the six outputs are already generated in the demo: board pack, Department return, readiness pack.</a:t>
             </a:r>
-            <a:endParaRPr lang="en-US" dirty="0"/>
           </a:p>
         </p:txBody>
       </p:sp>
@@ -1043,7 +847,6 @@
               <a:rPr lang="en-US" dirty="0"/>
               <a:t>Same platform DNA as connects.health — the Peppard dashboard is a sibling, not a one-off.</a:t>
             </a:r>
-            <a:endParaRPr lang="en-US" dirty="0"/>
           </a:p>
         </p:txBody>
       </p:sp>
@@ -1131,7 +934,6 @@
               <a:rPr lang="en-US" dirty="0"/>
               <a:t>Riverside carries the real 24.03.2026 inspection data; the other 7 centres carry representative sample data in the same shape.</a:t>
             </a:r>
-            <a:endParaRPr lang="en-US" dirty="0"/>
           </a:p>
         </p:txBody>
       </p:sp>
@@ -1219,7 +1021,6 @@
               <a:rPr lang="en-US" dirty="0"/>
               <a:t>The room table is the actual inspection data: bed configs, dimensions, issues like fridges in rooms.</a:t>
             </a:r>
-            <a:endParaRPr lang="en-US" dirty="0"/>
           </a:p>
         </p:txBody>
       </p:sp>
@@ -1307,7 +1108,6 @@
               <a:rPr lang="en-US" dirty="0"/>
               <a:t>This is the contractual exposure loop. RED = contractual breach; the clock starts on report receipt.</a:t>
             </a:r>
-            <a:endParaRPr lang="en-US" dirty="0"/>
           </a:p>
         </p:txBody>
       </p:sp>
@@ -1395,7 +1195,6 @@
               <a:rPr lang="en-US" dirty="0"/>
               <a:t>Benchmark recomputed from the raw judgement matrix of published inspections — Peppard's tracker data.</a:t>
             </a:r>
-            <a:endParaRPr lang="en-US" dirty="0"/>
           </a:p>
         </p:txBody>
       </p:sp>
@@ -1483,7 +1282,6 @@
               <a:rPr lang="en-US" dirty="0"/>
               <a:t>6 KPIs compute live today (occupancy, space standard, evidence timeliness, open REDs, mould cases, prohibited items). The rest wire up in Phase 2.</a:t>
             </a:r>
-            <a:endParaRPr lang="en-US" dirty="0"/>
           </a:p>
         </p:txBody>
       </p:sp>
@@ -1556,6 +1354,11 @@
 <file path=ppt/slideMasters/slideMaster1.xml><?xml version="1.0" encoding="utf-8"?>
 <p:sldMaster xmlns:a="http://schemas.openxmlformats.org/drawingml/2006/main" xmlns:r="http://schemas.openxmlformats.org/officeDocument/2006/relationships" xmlns:p="http://schemas.openxmlformats.org/presentationml/2006/main">
   <p:cSld>
+    <p:bg>
+      <p:bgRef idx="1001">
+        <a:schemeClr val="bg1"/>
+      </p:bgRef>
+    </p:bg>
     <p:spTree>
       <p:nvGrpSpPr>
         <p:cNvPr id="1" name=""/>
@@ -1838,6 +1641,7 @@
         <a:solidFill>
           <a:srgbClr val="FFFFFF"/>
         </a:solidFill>
+        <a:effectLst/>
       </p:bgPr>
     </p:bg>
     <p:spTree>
@@ -1856,22 +1660,22 @@
       </p:grpSpPr>
       <p:pic>
         <p:nvPicPr>
-          <p:cNvPr id="2" name="Image 0" descr="C:/Users/phoga/OneDrive/Documents/GitHub/peppard-ipas/public/peppard-logo.jpg">    </p:cNvPr>
+          <p:cNvPr id="2" name="Image 0" descr="C:/Users/phoga/OneDrive/Documents/GitHub/peppard-ipas/public/peppard-logo.jpg"/>
           <p:cNvPicPr>
             <a:picLocks noChangeAspect="1"/>
           </p:cNvPicPr>
           <p:nvPr/>
         </p:nvPicPr>
         <p:blipFill>
-          <a:blip r:embed="rId1"/>
+          <a:blip r:embed="rId3"/>
           <a:stretch>
             <a:fillRect/>
           </a:stretch>
         </p:blipFill>
         <p:spPr>
           <a:xfrm>
-            <a:off x="4956048" y="914400"/>
-            <a:ext cx="2286000" cy="1481328"/>
+            <a:off x="4956048" y="1293778"/>
+            <a:ext cx="2286000" cy="1101949"/>
           </a:xfrm>
           <a:prstGeom prst="rect">
             <a:avLst/>
@@ -1899,7 +1703,7 @@
           <a:bodyPr wrap="square" lIns="0" tIns="0" rIns="0" bIns="0" rtlCol="0" anchor="ctr"/>
           <a:lstStyle/>
           <a:p>
-            <a:pPr algn="ctr" indent="0" marL="0">
+            <a:pPr marL="0" indent="0" algn="ctr">
               <a:buNone/>
             </a:pPr>
             <a:r>
@@ -1938,7 +1742,7 @@
           <a:bodyPr wrap="square" lIns="0" tIns="0" rIns="0" bIns="0" rtlCol="0" anchor="ctr"/>
           <a:lstStyle/>
           <a:p>
-            <a:pPr algn="ctr" indent="0" marL="0">
+            <a:pPr marL="0" indent="0" algn="ctr">
               <a:buNone/>
             </a:pPr>
             <a:r>
@@ -1977,6 +1781,13 @@
           </a:solidFill>
           <a:ln/>
         </p:spPr>
+        <p:txBody>
+          <a:bodyPr/>
+          <a:lstStyle/>
+          <a:p>
+            <a:endParaRPr lang="en-IE"/>
+          </a:p>
+        </p:txBody>
       </p:sp>
       <p:sp>
         <p:nvSpPr>
@@ -1999,11 +1810,11 @@
           <a:bodyPr wrap="square" lIns="0" tIns="0" rIns="0" bIns="0" rtlCol="0" anchor="ctr"/>
           <a:lstStyle/>
           <a:p>
-            <a:pPr algn="ctr" indent="0" marL="0">
+            <a:pPr marL="0" indent="0" algn="ctr">
               <a:buNone/>
             </a:pPr>
             <a:r>
-              <a:rPr lang="en-US" sz="1000" b="1" spc="100" kern="0" dirty="0">
+              <a:rPr lang="en-US" sz="1000" b="1" kern="0" spc="100" dirty="0">
                 <a:solidFill>
                   <a:srgbClr val="26262A"/>
                 </a:solidFill>
@@ -2038,6 +1849,13 @@
           </a:solidFill>
           <a:ln/>
         </p:spPr>
+        <p:txBody>
+          <a:bodyPr/>
+          <a:lstStyle/>
+          <a:p>
+            <a:endParaRPr lang="en-IE"/>
+          </a:p>
+        </p:txBody>
       </p:sp>
       <p:sp>
         <p:nvSpPr>
@@ -2060,11 +1878,11 @@
           <a:bodyPr wrap="square" lIns="0" tIns="0" rIns="0" bIns="0" rtlCol="0" anchor="ctr"/>
           <a:lstStyle/>
           <a:p>
-            <a:pPr algn="ctr" indent="0" marL="0">
+            <a:pPr marL="0" indent="0" algn="ctr">
               <a:buNone/>
             </a:pPr>
             <a:r>
-              <a:rPr lang="en-US" sz="1000" b="1" spc="100" kern="0" dirty="0">
+              <a:rPr lang="en-US" sz="1000" b="1" kern="0" spc="100" dirty="0">
                 <a:solidFill>
                   <a:srgbClr val="FFFFFF"/>
                 </a:solidFill>
@@ -2099,6 +1917,13 @@
           </a:solidFill>
           <a:ln/>
         </p:spPr>
+        <p:txBody>
+          <a:bodyPr/>
+          <a:lstStyle/>
+          <a:p>
+            <a:endParaRPr lang="en-IE"/>
+          </a:p>
+        </p:txBody>
       </p:sp>
       <p:sp>
         <p:nvSpPr>
@@ -2121,11 +1946,11 @@
           <a:bodyPr wrap="square" lIns="0" tIns="0" rIns="0" bIns="0" rtlCol="0" anchor="ctr"/>
           <a:lstStyle/>
           <a:p>
-            <a:pPr algn="ctr" indent="0" marL="0">
+            <a:pPr marL="0" indent="0" algn="ctr">
               <a:buNone/>
             </a:pPr>
             <a:r>
-              <a:rPr lang="en-US" sz="1000" b="1" spc="100" kern="0" dirty="0">
+              <a:rPr lang="en-US" sz="1000" b="1" kern="0" spc="100" dirty="0">
                 <a:solidFill>
                   <a:srgbClr val="26262A"/>
                 </a:solidFill>
@@ -2160,7 +1985,7 @@
           <a:bodyPr wrap="square" lIns="0" tIns="0" rIns="0" bIns="0" rtlCol="0" anchor="ctr"/>
           <a:lstStyle/>
           <a:p>
-            <a:pPr algn="ctr" indent="0" marL="0">
+            <a:pPr marL="0" indent="0" algn="ctr">
               <a:buNone/>
             </a:pPr>
             <a:r>
@@ -2194,6 +2019,7 @@
         <a:solidFill>
           <a:srgbClr val="FFFFFF"/>
         </a:solidFill>
+        <a:effectLst/>
       </p:bgPr>
     </p:bg>
     <p:spTree>
@@ -2231,6 +2057,13 @@
           </a:solidFill>
           <a:ln/>
         </p:spPr>
+        <p:txBody>
+          <a:bodyPr/>
+          <a:lstStyle/>
+          <a:p>
+            <a:endParaRPr lang="en-IE"/>
+          </a:p>
+        </p:txBody>
       </p:sp>
       <p:sp>
         <p:nvSpPr>
@@ -2253,11 +2086,11 @@
           <a:bodyPr wrap="square" lIns="0" tIns="0" rIns="0" bIns="0" rtlCol="0" anchor="ctr"/>
           <a:lstStyle/>
           <a:p>
-            <a:pPr algn="ctr" indent="0" marL="0">
+            <a:pPr marL="0" indent="0" algn="ctr">
               <a:buNone/>
             </a:pPr>
             <a:r>
-              <a:rPr lang="en-US" sz="1000" b="1" spc="100" kern="0" dirty="0">
+              <a:rPr lang="en-US" sz="1000" b="1" kern="0" spc="100" dirty="0">
                 <a:solidFill>
                   <a:srgbClr val="FFFFFF"/>
                 </a:solidFill>
@@ -2292,7 +2125,7 @@
           <a:bodyPr wrap="square" lIns="0" tIns="0" rIns="0" bIns="0" rtlCol="0" anchor="ctr"/>
           <a:lstStyle/>
           <a:p>
-            <a:pPr indent="0" marL="0">
+            <a:pPr marL="0" indent="0">
               <a:buNone/>
             </a:pPr>
             <a:r>
@@ -2312,211 +2145,7 @@
       </p:sp>
       <p:pic>
         <p:nvPicPr>
-          <p:cNvPr id="5" name="Image 0" descr="C:/Users/phoga/OneDrive/Documents/GitHub/peppard-ipas/docs/screens/06-readiness-pack.png">    </p:cNvPr>
-          <p:cNvPicPr>
-            <a:picLocks noChangeAspect="1"/>
-          </p:cNvPicPr>
-          <p:nvPr/>
-        </p:nvPicPr>
-        <p:blipFill>
-          <a:blip r:embed="rId1"/>
-          <a:stretch>
-            <a:fillRect/>
-          </a:stretch>
-        </p:blipFill>
-        <p:spPr>
-          <a:xfrm>
-            <a:off x="502920" y="1554480"/>
-            <a:ext cx="3566160" cy="2231136"/>
-          </a:xfrm>
-          <a:prstGeom prst="rect">
-            <a:avLst/>
-          </a:prstGeom>
-        </p:spPr>
-      </p:pic>
-      <p:sp>
-        <p:nvSpPr>
-          <p:cNvPr id="6" name="Text 3"/>
-          <p:cNvSpPr/>
-          <p:nvPr/>
-        </p:nvSpPr>
-        <p:spPr>
-          <a:xfrm>
-            <a:off x="502920" y="3931920"/>
-            <a:ext cx="3566160" cy="320040"/>
-          </a:xfrm>
-          <a:prstGeom prst="rect">
-            <a:avLst/>
-          </a:prstGeom>
-          <a:noFill/>
-          <a:ln/>
-        </p:spPr>
-        <p:txBody>
-          <a:bodyPr wrap="square" lIns="0" tIns="0" rIns="0" bIns="0" rtlCol="0" anchor="ctr"/>
-          <a:lstStyle/>
-          <a:p>
-            <a:pPr indent="0" marL="0">
-              <a:buNone/>
-            </a:pPr>
-            <a:r>
-              <a:rPr lang="en-US" sz="1500" b="1" dirty="0">
-                <a:solidFill>
-                  <a:srgbClr val="26262A"/>
-                </a:solidFill>
-                <a:latin typeface="Cambria" pitchFamily="34" charset="0"/>
-                <a:ea typeface="Cambria" pitchFamily="34" charset="-122"/>
-                <a:cs typeface="Cambria" pitchFamily="34" charset="-120"/>
-              </a:rPr>
-              <a:t>Inspection readiness pack</a:t>
-            </a:r>
-            <a:endParaRPr lang="en-US" sz="1500" dirty="0"/>
-          </a:p>
-        </p:txBody>
-      </p:sp>
-      <p:sp>
-        <p:nvSpPr>
-          <p:cNvPr id="7" name="Text 4"/>
-          <p:cNvSpPr/>
-          <p:nvPr/>
-        </p:nvSpPr>
-        <p:spPr>
-          <a:xfrm>
-            <a:off x="502920" y="4261104"/>
-            <a:ext cx="3566160" cy="502920"/>
-          </a:xfrm>
-          <a:prstGeom prst="rect">
-            <a:avLst/>
-          </a:prstGeom>
-          <a:noFill/>
-          <a:ln/>
-        </p:spPr>
-        <p:txBody>
-          <a:bodyPr wrap="square" lIns="0" tIns="0" rIns="0" bIns="0" rtlCol="0" anchor="ctr"/>
-          <a:lstStyle/>
-          <a:p>
-            <a:pPr indent="0" marL="0">
-              <a:buNone/>
-            </a:pPr>
-            <a:r>
-              <a:rPr lang="en-US" sz="1150" dirty="0">
-                <a:solidFill>
-                  <a:srgbClr val="5F5C60"/>
-                </a:solidFill>
-                <a:latin typeface="Calibri" pitchFamily="34" charset="0"/>
-                <a:ea typeface="Calibri" pitchFamily="34" charset="-122"/>
-                <a:cs typeface="Calibri" pitchFamily="34" charset="-120"/>
-              </a:rPr>
-              <a:t>Everything an inspector asks for, print-ready</a:t>
-            </a:r>
-            <a:endParaRPr lang="en-US" sz="1150" dirty="0"/>
-          </a:p>
-        </p:txBody>
-      </p:sp>
-      <p:pic>
-        <p:nvPicPr>
-          <p:cNvPr id="8" name="Image 1" descr="C:/Users/phoga/OneDrive/Documents/GitHub/peppard-ipas/docs/screens/07-board-pack.png">    </p:cNvPr>
-          <p:cNvPicPr>
-            <a:picLocks noChangeAspect="1"/>
-          </p:cNvPicPr>
-          <p:nvPr/>
-        </p:nvPicPr>
-        <p:blipFill>
-          <a:blip r:embed="rId2"/>
-          <a:stretch>
-            <a:fillRect/>
-          </a:stretch>
-        </p:blipFill>
-        <p:spPr>
-          <a:xfrm>
-            <a:off x="4297680" y="1554480"/>
-            <a:ext cx="3566160" cy="2231136"/>
-          </a:xfrm>
-          <a:prstGeom prst="rect">
-            <a:avLst/>
-          </a:prstGeom>
-        </p:spPr>
-      </p:pic>
-      <p:sp>
-        <p:nvSpPr>
-          <p:cNvPr id="9" name="Text 5"/>
-          <p:cNvSpPr/>
-          <p:nvPr/>
-        </p:nvSpPr>
-        <p:spPr>
-          <a:xfrm>
-            <a:off x="4297680" y="3931920"/>
-            <a:ext cx="3566160" cy="320040"/>
-          </a:xfrm>
-          <a:prstGeom prst="rect">
-            <a:avLst/>
-          </a:prstGeom>
-          <a:noFill/>
-          <a:ln/>
-        </p:spPr>
-        <p:txBody>
-          <a:bodyPr wrap="square" lIns="0" tIns="0" rIns="0" bIns="0" rtlCol="0" anchor="ctr"/>
-          <a:lstStyle/>
-          <a:p>
-            <a:pPr indent="0" marL="0">
-              <a:buNone/>
-            </a:pPr>
-            <a:r>
-              <a:rPr lang="en-US" sz="1500" b="1" dirty="0">
-                <a:solidFill>
-                  <a:srgbClr val="26262A"/>
-                </a:solidFill>
-                <a:latin typeface="Cambria" pitchFamily="34" charset="0"/>
-                <a:ea typeface="Cambria" pitchFamily="34" charset="-122"/>
-                <a:cs typeface="Cambria" pitchFamily="34" charset="-120"/>
-              </a:rPr>
-              <a:t>Quarterly board pack</a:t>
-            </a:r>
-            <a:endParaRPr lang="en-US" sz="1500" dirty="0"/>
-          </a:p>
-        </p:txBody>
-      </p:sp>
-      <p:sp>
-        <p:nvSpPr>
-          <p:cNvPr id="10" name="Text 6"/>
-          <p:cNvSpPr/>
-          <p:nvPr/>
-        </p:nvSpPr>
-        <p:spPr>
-          <a:xfrm>
-            <a:off x="4297680" y="4261104"/>
-            <a:ext cx="3566160" cy="502920"/>
-          </a:xfrm>
-          <a:prstGeom prst="rect">
-            <a:avLst/>
-          </a:prstGeom>
-          <a:noFill/>
-          <a:ln/>
-        </p:spPr>
-        <p:txBody>
-          <a:bodyPr wrap="square" lIns="0" tIns="0" rIns="0" bIns="0" rtlCol="0" anchor="ctr"/>
-          <a:lstStyle/>
-          <a:p>
-            <a:pPr indent="0" marL="0">
-              <a:buNone/>
-            </a:pPr>
-            <a:r>
-              <a:rPr lang="en-US" sz="1150" dirty="0">
-                <a:solidFill>
-                  <a:srgbClr val="5F5C60"/>
-                </a:solidFill>
-                <a:latin typeface="Calibri" pitchFamily="34" charset="0"/>
-                <a:ea typeface="Calibri" pitchFamily="34" charset="-122"/>
-                <a:cs typeface="Calibri" pitchFamily="34" charset="-120"/>
-              </a:rPr>
-              <a:t>Group position, centre RAG, thematic risks</a:t>
-            </a:r>
-            <a:endParaRPr lang="en-US" sz="1150" dirty="0"/>
-          </a:p>
-        </p:txBody>
-      </p:sp>
-      <p:pic>
-        <p:nvPicPr>
-          <p:cNvPr id="11" name="Image 2" descr="C:/Users/phoga/OneDrive/Documents/GitHub/peppard-ipas/docs/screens/08-dept-return.png">    </p:cNvPr>
+          <p:cNvPr id="5" name="Image 0" descr="C:/Users/phoga/OneDrive/Documents/GitHub/peppard-ipas/docs/screens/06-readiness-pack.png"/>
           <p:cNvPicPr>
             <a:picLocks noChangeAspect="1"/>
           </p:cNvPicPr>
@@ -2530,7 +2159,7 @@
         </p:blipFill>
         <p:spPr>
           <a:xfrm>
-            <a:off x="8092440" y="1554480"/>
+            <a:off x="502920" y="1554480"/>
             <a:ext cx="3566160" cy="2231136"/>
           </a:xfrm>
           <a:prstGeom prst="rect">
@@ -2540,13 +2169,13 @@
       </p:pic>
       <p:sp>
         <p:nvSpPr>
-          <p:cNvPr id="12" name="Text 7"/>
-          <p:cNvSpPr/>
-          <p:nvPr/>
-        </p:nvSpPr>
-        <p:spPr>
-          <a:xfrm>
-            <a:off x="8092440" y="3931920"/>
+          <p:cNvPr id="6" name="Text 3"/>
+          <p:cNvSpPr/>
+          <p:nvPr/>
+        </p:nvSpPr>
+        <p:spPr>
+          <a:xfrm>
+            <a:off x="502920" y="3931920"/>
             <a:ext cx="3566160" cy="320040"/>
           </a:xfrm>
           <a:prstGeom prst="rect">
@@ -2559,7 +2188,7 @@
           <a:bodyPr wrap="square" lIns="0" tIns="0" rIns="0" bIns="0" rtlCol="0" anchor="ctr"/>
           <a:lstStyle/>
           <a:p>
-            <a:pPr indent="0" marL="0">
+            <a:pPr marL="0" indent="0">
               <a:buNone/>
             </a:pPr>
             <a:r>
@@ -2571,6 +2200,210 @@
                 <a:ea typeface="Cambria" pitchFamily="34" charset="-122"/>
                 <a:cs typeface="Cambria" pitchFamily="34" charset="-120"/>
               </a:rPr>
+              <a:t>Inspection readiness pack</a:t>
+            </a:r>
+            <a:endParaRPr lang="en-US" sz="1500" dirty="0"/>
+          </a:p>
+        </p:txBody>
+      </p:sp>
+      <p:sp>
+        <p:nvSpPr>
+          <p:cNvPr id="7" name="Text 4"/>
+          <p:cNvSpPr/>
+          <p:nvPr/>
+        </p:nvSpPr>
+        <p:spPr>
+          <a:xfrm>
+            <a:off x="502920" y="4261104"/>
+            <a:ext cx="3566160" cy="502920"/>
+          </a:xfrm>
+          <a:prstGeom prst="rect">
+            <a:avLst/>
+          </a:prstGeom>
+          <a:noFill/>
+          <a:ln/>
+        </p:spPr>
+        <p:txBody>
+          <a:bodyPr wrap="square" lIns="0" tIns="0" rIns="0" bIns="0" rtlCol="0" anchor="ctr"/>
+          <a:lstStyle/>
+          <a:p>
+            <a:pPr marL="0" indent="0">
+              <a:buNone/>
+            </a:pPr>
+            <a:r>
+              <a:rPr lang="en-US" sz="1150" dirty="0">
+                <a:solidFill>
+                  <a:srgbClr val="5F5C60"/>
+                </a:solidFill>
+                <a:latin typeface="Calibri" pitchFamily="34" charset="0"/>
+                <a:ea typeface="Calibri" pitchFamily="34" charset="-122"/>
+                <a:cs typeface="Calibri" pitchFamily="34" charset="-120"/>
+              </a:rPr>
+              <a:t>Everything an inspector asks for, print-ready</a:t>
+            </a:r>
+            <a:endParaRPr lang="en-US" sz="1150" dirty="0"/>
+          </a:p>
+        </p:txBody>
+      </p:sp>
+      <p:pic>
+        <p:nvPicPr>
+          <p:cNvPr id="8" name="Image 1" descr="C:/Users/phoga/OneDrive/Documents/GitHub/peppard-ipas/docs/screens/07-board-pack.png"/>
+          <p:cNvPicPr>
+            <a:picLocks noChangeAspect="1"/>
+          </p:cNvPicPr>
+          <p:nvPr/>
+        </p:nvPicPr>
+        <p:blipFill>
+          <a:blip r:embed="rId4"/>
+          <a:stretch>
+            <a:fillRect/>
+          </a:stretch>
+        </p:blipFill>
+        <p:spPr>
+          <a:xfrm>
+            <a:off x="4297680" y="1554480"/>
+            <a:ext cx="3566160" cy="2231136"/>
+          </a:xfrm>
+          <a:prstGeom prst="rect">
+            <a:avLst/>
+          </a:prstGeom>
+        </p:spPr>
+      </p:pic>
+      <p:sp>
+        <p:nvSpPr>
+          <p:cNvPr id="9" name="Text 5"/>
+          <p:cNvSpPr/>
+          <p:nvPr/>
+        </p:nvSpPr>
+        <p:spPr>
+          <a:xfrm>
+            <a:off x="4297680" y="3931920"/>
+            <a:ext cx="3566160" cy="320040"/>
+          </a:xfrm>
+          <a:prstGeom prst="rect">
+            <a:avLst/>
+          </a:prstGeom>
+          <a:noFill/>
+          <a:ln/>
+        </p:spPr>
+        <p:txBody>
+          <a:bodyPr wrap="square" lIns="0" tIns="0" rIns="0" bIns="0" rtlCol="0" anchor="ctr"/>
+          <a:lstStyle/>
+          <a:p>
+            <a:pPr marL="0" indent="0">
+              <a:buNone/>
+            </a:pPr>
+            <a:r>
+              <a:rPr lang="en-US" sz="1500" b="1" dirty="0">
+                <a:solidFill>
+                  <a:srgbClr val="26262A"/>
+                </a:solidFill>
+                <a:latin typeface="Cambria" pitchFamily="34" charset="0"/>
+                <a:ea typeface="Cambria" pitchFamily="34" charset="-122"/>
+                <a:cs typeface="Cambria" pitchFamily="34" charset="-120"/>
+              </a:rPr>
+              <a:t>Quarterly board pack</a:t>
+            </a:r>
+            <a:endParaRPr lang="en-US" sz="1500" dirty="0"/>
+          </a:p>
+        </p:txBody>
+      </p:sp>
+      <p:sp>
+        <p:nvSpPr>
+          <p:cNvPr id="10" name="Text 6"/>
+          <p:cNvSpPr/>
+          <p:nvPr/>
+        </p:nvSpPr>
+        <p:spPr>
+          <a:xfrm>
+            <a:off x="4297680" y="4261104"/>
+            <a:ext cx="3566160" cy="502920"/>
+          </a:xfrm>
+          <a:prstGeom prst="rect">
+            <a:avLst/>
+          </a:prstGeom>
+          <a:noFill/>
+          <a:ln/>
+        </p:spPr>
+        <p:txBody>
+          <a:bodyPr wrap="square" lIns="0" tIns="0" rIns="0" bIns="0" rtlCol="0" anchor="ctr"/>
+          <a:lstStyle/>
+          <a:p>
+            <a:pPr marL="0" indent="0">
+              <a:buNone/>
+            </a:pPr>
+            <a:r>
+              <a:rPr lang="en-US" sz="1150" dirty="0">
+                <a:solidFill>
+                  <a:srgbClr val="5F5C60"/>
+                </a:solidFill>
+                <a:latin typeface="Calibri" pitchFamily="34" charset="0"/>
+                <a:ea typeface="Calibri" pitchFamily="34" charset="-122"/>
+                <a:cs typeface="Calibri" pitchFamily="34" charset="-120"/>
+              </a:rPr>
+              <a:t>Group position, centre RAG, thematic risks</a:t>
+            </a:r>
+            <a:endParaRPr lang="en-US" sz="1150" dirty="0"/>
+          </a:p>
+        </p:txBody>
+      </p:sp>
+      <p:pic>
+        <p:nvPicPr>
+          <p:cNvPr id="11" name="Image 2" descr="C:/Users/phoga/OneDrive/Documents/GitHub/peppard-ipas/docs/screens/08-dept-return.png"/>
+          <p:cNvPicPr>
+            <a:picLocks noChangeAspect="1"/>
+          </p:cNvPicPr>
+          <p:nvPr/>
+        </p:nvPicPr>
+        <p:blipFill>
+          <a:blip r:embed="rId5"/>
+          <a:stretch>
+            <a:fillRect/>
+          </a:stretch>
+        </p:blipFill>
+        <p:spPr>
+          <a:xfrm>
+            <a:off x="8092440" y="1554480"/>
+            <a:ext cx="3566160" cy="2231136"/>
+          </a:xfrm>
+          <a:prstGeom prst="rect">
+            <a:avLst/>
+          </a:prstGeom>
+        </p:spPr>
+      </p:pic>
+      <p:sp>
+        <p:nvSpPr>
+          <p:cNvPr id="12" name="Text 7"/>
+          <p:cNvSpPr/>
+          <p:nvPr/>
+        </p:nvSpPr>
+        <p:spPr>
+          <a:xfrm>
+            <a:off x="8092440" y="3931920"/>
+            <a:ext cx="3566160" cy="320040"/>
+          </a:xfrm>
+          <a:prstGeom prst="rect">
+            <a:avLst/>
+          </a:prstGeom>
+          <a:noFill/>
+          <a:ln/>
+        </p:spPr>
+        <p:txBody>
+          <a:bodyPr wrap="square" lIns="0" tIns="0" rIns="0" bIns="0" rtlCol="0" anchor="ctr"/>
+          <a:lstStyle/>
+          <a:p>
+            <a:pPr marL="0" indent="0">
+              <a:buNone/>
+            </a:pPr>
+            <a:r>
+              <a:rPr lang="en-US" sz="1500" b="1" dirty="0">
+                <a:solidFill>
+                  <a:srgbClr val="26262A"/>
+                </a:solidFill>
+                <a:latin typeface="Cambria" pitchFamily="34" charset="0"/>
+                <a:ea typeface="Cambria" pitchFamily="34" charset="-122"/>
+                <a:cs typeface="Cambria" pitchFamily="34" charset="-120"/>
+              </a:rPr>
               <a:t>Department return</a:t>
             </a:r>
             <a:endParaRPr lang="en-US" sz="1500" dirty="0"/>
@@ -2598,7 +2431,7 @@
           <a:bodyPr wrap="square" lIns="0" tIns="0" rIns="0" bIns="0" rtlCol="0" anchor="ctr"/>
           <a:lstStyle/>
           <a:p>
-            <a:pPr indent="0" marL="0">
+            <a:pPr marL="0" indent="0">
               <a:buNone/>
             </a:pPr>
             <a:r>
@@ -2637,7 +2470,7 @@
           <a:bodyPr wrap="square" lIns="0" tIns="0" rIns="0" bIns="0" rtlCol="0" anchor="ctr"/>
           <a:lstStyle/>
           <a:p>
-            <a:pPr algn="ctr" indent="0" marL="0">
+            <a:pPr marL="0" indent="0" algn="ctr">
               <a:buNone/>
             </a:pPr>
             <a:r>
@@ -2654,7 +2487,7 @@
             <a:endParaRPr lang="en-US" sz="1400" dirty="0"/>
           </a:p>
           <a:p>
-            <a:pPr algn="ctr" indent="0" marL="0">
+            <a:pPr marL="0" indent="0" algn="ctr">
               <a:buNone/>
             </a:pPr>
             <a:r>
@@ -2688,6 +2521,7 @@
         <a:solidFill>
           <a:srgbClr val="FFFFFF"/>
         </a:solidFill>
+        <a:effectLst/>
       </p:bgPr>
     </p:bg>
     <p:spTree>
@@ -2725,6 +2559,13 @@
           </a:solidFill>
           <a:ln/>
         </p:spPr>
+        <p:txBody>
+          <a:bodyPr/>
+          <a:lstStyle/>
+          <a:p>
+            <a:endParaRPr lang="en-IE"/>
+          </a:p>
+        </p:txBody>
       </p:sp>
       <p:sp>
         <p:nvSpPr>
@@ -2747,11 +2588,11 @@
           <a:bodyPr wrap="square" lIns="0" tIns="0" rIns="0" bIns="0" rtlCol="0" anchor="ctr"/>
           <a:lstStyle/>
           <a:p>
-            <a:pPr algn="ctr" indent="0" marL="0">
+            <a:pPr marL="0" indent="0" algn="ctr">
               <a:buNone/>
             </a:pPr>
             <a:r>
-              <a:rPr lang="en-US" sz="1000" b="1" spc="100" kern="0" dirty="0">
+              <a:rPr lang="en-US" sz="1000" b="1" kern="0" spc="100" dirty="0">
                 <a:solidFill>
                   <a:srgbClr val="FFFFFF"/>
                 </a:solidFill>
@@ -2786,7 +2627,7 @@
           <a:bodyPr wrap="square" lIns="0" tIns="0" rIns="0" bIns="0" rtlCol="0" anchor="ctr"/>
           <a:lstStyle/>
           <a:p>
-            <a:pPr indent="0" marL="0">
+            <a:pPr marL="0" indent="0">
               <a:buNone/>
             </a:pPr>
             <a:r>
@@ -2825,6 +2666,13 @@
           </a:solidFill>
           <a:ln/>
         </p:spPr>
+        <p:txBody>
+          <a:bodyPr/>
+          <a:lstStyle/>
+          <a:p>
+            <a:endParaRPr lang="en-IE"/>
+          </a:p>
+        </p:txBody>
       </p:sp>
       <p:sp>
         <p:nvSpPr>
@@ -2847,7 +2695,7 @@
           <a:bodyPr wrap="square" lIns="0" tIns="0" rIns="0" bIns="0" rtlCol="0" anchor="ctr"/>
           <a:lstStyle/>
           <a:p>
-            <a:pPr indent="0" marL="0">
+            <a:pPr marL="0" indent="0">
               <a:buNone/>
             </a:pPr>
             <a:r>
@@ -3018,6 +2866,13 @@
             <a:prstDash val="solid"/>
           </a:ln>
         </p:spPr>
+        <p:txBody>
+          <a:bodyPr/>
+          <a:lstStyle/>
+          <a:p>
+            <a:endParaRPr lang="en-IE"/>
+          </a:p>
+        </p:txBody>
       </p:sp>
       <p:sp>
         <p:nvSpPr>
@@ -3040,7 +2895,7 @@
           <a:bodyPr wrap="square" lIns="0" tIns="0" rIns="0" bIns="0" rtlCol="0" anchor="ctr"/>
           <a:lstStyle/>
           <a:p>
-            <a:pPr indent="0" marL="0">
+            <a:pPr marL="0" indent="0">
               <a:buNone/>
             </a:pPr>
             <a:r>
@@ -3079,6 +2934,13 @@
           </a:solidFill>
           <a:ln/>
         </p:spPr>
+        <p:txBody>
+          <a:bodyPr/>
+          <a:lstStyle/>
+          <a:p>
+            <a:endParaRPr lang="en-IE"/>
+          </a:p>
+        </p:txBody>
       </p:sp>
       <p:sp>
         <p:nvSpPr>
@@ -3101,11 +2963,11 @@
           <a:bodyPr wrap="square" lIns="0" tIns="0" rIns="0" bIns="0" rtlCol="0" anchor="ctr"/>
           <a:lstStyle/>
           <a:p>
-            <a:pPr algn="ctr" indent="0" marL="0">
+            <a:pPr marL="0" indent="0" algn="ctr">
               <a:buNone/>
             </a:pPr>
             <a:r>
-              <a:rPr lang="en-US" sz="1000" b="1" spc="100" kern="0" dirty="0">
+              <a:rPr lang="en-US" sz="1000" b="1" kern="0" spc="100" dirty="0">
                 <a:solidFill>
                   <a:srgbClr val="FFFFFF"/>
                 </a:solidFill>
@@ -3140,7 +3002,7 @@
           <a:bodyPr wrap="square" lIns="0" tIns="0" rIns="0" bIns="0" rtlCol="0" anchor="t"/>
           <a:lstStyle/>
           <a:p>
-            <a:pPr indent="0" marL="0">
+            <a:pPr marL="0" indent="0">
               <a:buNone/>
             </a:pPr>
             <a:r>
@@ -3179,6 +3041,13 @@
           </a:solidFill>
           <a:ln/>
         </p:spPr>
+        <p:txBody>
+          <a:bodyPr/>
+          <a:lstStyle/>
+          <a:p>
+            <a:endParaRPr lang="en-IE"/>
+          </a:p>
+        </p:txBody>
       </p:sp>
       <p:sp>
         <p:nvSpPr>
@@ -3201,11 +3070,11 @@
           <a:bodyPr wrap="square" lIns="0" tIns="0" rIns="0" bIns="0" rtlCol="0" anchor="ctr"/>
           <a:lstStyle/>
           <a:p>
-            <a:pPr algn="ctr" indent="0" marL="0">
+            <a:pPr marL="0" indent="0" algn="ctr">
               <a:buNone/>
             </a:pPr>
             <a:r>
-              <a:rPr lang="en-US" sz="1000" b="1" spc="100" kern="0" dirty="0">
+              <a:rPr lang="en-US" sz="1000" b="1" kern="0" spc="100" dirty="0">
                 <a:solidFill>
                   <a:srgbClr val="FFFFFF"/>
                 </a:solidFill>
@@ -3240,7 +3109,7 @@
           <a:bodyPr wrap="square" lIns="0" tIns="0" rIns="0" bIns="0" rtlCol="0" anchor="t"/>
           <a:lstStyle/>
           <a:p>
-            <a:pPr indent="0" marL="0">
+            <a:pPr marL="0" indent="0">
               <a:buNone/>
             </a:pPr>
             <a:r>
@@ -3279,6 +3148,13 @@
           </a:solidFill>
           <a:ln/>
         </p:spPr>
+        <p:txBody>
+          <a:bodyPr/>
+          <a:lstStyle/>
+          <a:p>
+            <a:endParaRPr lang="en-IE"/>
+          </a:p>
+        </p:txBody>
       </p:sp>
       <p:sp>
         <p:nvSpPr>
@@ -3301,11 +3177,11 @@
           <a:bodyPr wrap="square" lIns="0" tIns="0" rIns="0" bIns="0" rtlCol="0" anchor="ctr"/>
           <a:lstStyle/>
           <a:p>
-            <a:pPr algn="ctr" indent="0" marL="0">
+            <a:pPr marL="0" indent="0" algn="ctr">
               <a:buNone/>
             </a:pPr>
             <a:r>
-              <a:rPr lang="en-US" sz="1000" b="1" spc="100" kern="0" dirty="0">
+              <a:rPr lang="en-US" sz="1000" b="1" kern="0" spc="100" dirty="0">
                 <a:solidFill>
                   <a:srgbClr val="FFFFFF"/>
                 </a:solidFill>
@@ -3340,7 +3216,7 @@
           <a:bodyPr wrap="square" lIns="0" tIns="0" rIns="0" bIns="0" rtlCol="0" anchor="t"/>
           <a:lstStyle/>
           <a:p>
-            <a:pPr indent="0" marL="0">
+            <a:pPr marL="0" indent="0">
               <a:buNone/>
             </a:pPr>
             <a:r>
@@ -3379,7 +3255,7 @@
           <a:bodyPr wrap="square" lIns="0" tIns="0" rIns="0" bIns="0" rtlCol="0" anchor="ctr"/>
           <a:lstStyle/>
           <a:p>
-            <a:pPr algn="ctr" indent="0" marL="0">
+            <a:pPr marL="0" indent="0" algn="ctr">
               <a:buNone/>
             </a:pPr>
             <a:r>
@@ -3413,6 +3289,7 @@
         <a:solidFill>
           <a:srgbClr val="00465C"/>
         </a:solidFill>
+        <a:effectLst/>
       </p:bgPr>
     </p:bg>
     <p:spTree>
@@ -3450,7 +3327,7 @@
           <a:bodyPr wrap="square" lIns="0" tIns="0" rIns="0" bIns="0" rtlCol="0" anchor="ctr"/>
           <a:lstStyle/>
           <a:p>
-            <a:pPr algn="ctr" indent="0" marL="0">
+            <a:pPr marL="0" indent="0" algn="ctr">
               <a:buNone/>
             </a:pPr>
             <a:r>
@@ -3489,7 +3366,7 @@
           <a:bodyPr wrap="square" lIns="0" tIns="0" rIns="0" bIns="0" rtlCol="0" anchor="ctr"/>
           <a:lstStyle/>
           <a:p>
-            <a:pPr algn="ctr" indent="0" marL="0">
+            <a:pPr marL="0" indent="0" algn="ctr">
               <a:buNone/>
             </a:pPr>
             <a:r>
@@ -3528,6 +3405,13 @@
           </a:solidFill>
           <a:ln/>
         </p:spPr>
+        <p:txBody>
+          <a:bodyPr/>
+          <a:lstStyle/>
+          <a:p>
+            <a:endParaRPr lang="en-IE"/>
+          </a:p>
+        </p:txBody>
       </p:sp>
       <p:sp>
         <p:nvSpPr>
@@ -3550,11 +3434,11 @@
           <a:bodyPr wrap="square" lIns="0" tIns="0" rIns="0" bIns="0" rtlCol="0" anchor="ctr"/>
           <a:lstStyle/>
           <a:p>
-            <a:pPr algn="ctr" indent="0" marL="0">
+            <a:pPr marL="0" indent="0" algn="ctr">
               <a:buNone/>
             </a:pPr>
             <a:r>
-              <a:rPr lang="en-US" sz="1000" b="1" spc="100" kern="0" dirty="0">
+              <a:rPr lang="en-US" sz="1000" b="1" kern="0" spc="100" dirty="0">
                 <a:solidFill>
                   <a:srgbClr val="FFFFFF"/>
                 </a:solidFill>
@@ -3584,6 +3468,7 @@
         <a:solidFill>
           <a:srgbClr val="FFFFFF"/>
         </a:solidFill>
+        <a:effectLst/>
       </p:bgPr>
     </p:bg>
     <p:spTree>
@@ -3621,6 +3506,13 @@
           </a:solidFill>
           <a:ln/>
         </p:spPr>
+        <p:txBody>
+          <a:bodyPr/>
+          <a:lstStyle/>
+          <a:p>
+            <a:endParaRPr lang="en-IE"/>
+          </a:p>
+        </p:txBody>
       </p:sp>
       <p:sp>
         <p:nvSpPr>
@@ -3643,11 +3535,11 @@
           <a:bodyPr wrap="square" lIns="0" tIns="0" rIns="0" bIns="0" rtlCol="0" anchor="ctr"/>
           <a:lstStyle/>
           <a:p>
-            <a:pPr algn="ctr" indent="0" marL="0">
+            <a:pPr marL="0" indent="0" algn="ctr">
               <a:buNone/>
             </a:pPr>
             <a:r>
-              <a:rPr lang="en-US" sz="1000" b="1" spc="100" kern="0" dirty="0">
+              <a:rPr lang="en-US" sz="1000" b="1" kern="0" spc="100" dirty="0">
                 <a:solidFill>
                   <a:srgbClr val="FFFFFF"/>
                 </a:solidFill>
@@ -3682,7 +3574,7 @@
           <a:bodyPr wrap="square" lIns="0" tIns="0" rIns="0" bIns="0" rtlCol="0" anchor="ctr"/>
           <a:lstStyle/>
           <a:p>
-            <a:pPr indent="0" marL="0">
+            <a:pPr marL="0" indent="0">
               <a:buNone/>
             </a:pPr>
             <a:r>
@@ -3726,6 +3618,13 @@
             <a:prstDash val="solid"/>
           </a:ln>
         </p:spPr>
+        <p:txBody>
+          <a:bodyPr/>
+          <a:lstStyle/>
+          <a:p>
+            <a:endParaRPr lang="en-IE"/>
+          </a:p>
+        </p:txBody>
       </p:sp>
       <p:sp>
         <p:nvSpPr>
@@ -3748,7 +3647,7 @@
           <a:bodyPr wrap="square" lIns="0" tIns="0" rIns="0" bIns="0" rtlCol="0" anchor="ctr"/>
           <a:lstStyle/>
           <a:p>
-            <a:pPr indent="0" marL="0">
+            <a:pPr marL="0" indent="0">
               <a:buNone/>
             </a:pPr>
             <a:r>
@@ -3914,6 +3813,13 @@
           </a:solidFill>
           <a:ln/>
         </p:spPr>
+        <p:txBody>
+          <a:bodyPr/>
+          <a:lstStyle/>
+          <a:p>
+            <a:endParaRPr lang="en-IE"/>
+          </a:p>
+        </p:txBody>
       </p:sp>
       <p:sp>
         <p:nvSpPr>
@@ -3936,11 +3842,11 @@
           <a:bodyPr wrap="square" lIns="0" tIns="0" rIns="0" bIns="0" rtlCol="0" anchor="ctr"/>
           <a:lstStyle/>
           <a:p>
-            <a:pPr algn="ctr" indent="0" marL="0">
+            <a:pPr marL="0" indent="0" algn="ctr">
               <a:buNone/>
             </a:pPr>
             <a:r>
-              <a:rPr lang="en-US" sz="1000" b="1" spc="100" kern="0" dirty="0">
+              <a:rPr lang="en-US" sz="1000" b="1" kern="0" spc="100" dirty="0">
                 <a:solidFill>
                   <a:srgbClr val="FFFFFF"/>
                 </a:solidFill>
@@ -3975,6 +3881,13 @@
           </a:solidFill>
           <a:ln/>
         </p:spPr>
+        <p:txBody>
+          <a:bodyPr/>
+          <a:lstStyle/>
+          <a:p>
+            <a:endParaRPr lang="en-IE"/>
+          </a:p>
+        </p:txBody>
       </p:sp>
       <p:sp>
         <p:nvSpPr>
@@ -3997,11 +3910,11 @@
           <a:bodyPr wrap="square" lIns="0" tIns="0" rIns="0" bIns="0" rtlCol="0" anchor="ctr"/>
           <a:lstStyle/>
           <a:p>
-            <a:pPr algn="ctr" indent="0" marL="0">
+            <a:pPr marL="0" indent="0" algn="ctr">
               <a:buNone/>
             </a:pPr>
             <a:r>
-              <a:rPr lang="en-US" sz="1000" b="1" spc="100" kern="0" dirty="0">
+              <a:rPr lang="en-US" sz="1000" b="1" kern="0" spc="100" dirty="0">
                 <a:solidFill>
                   <a:srgbClr val="E65100"/>
                 </a:solidFill>
@@ -4036,6 +3949,13 @@
           </a:solidFill>
           <a:ln/>
         </p:spPr>
+        <p:txBody>
+          <a:bodyPr/>
+          <a:lstStyle/>
+          <a:p>
+            <a:endParaRPr lang="en-IE"/>
+          </a:p>
+        </p:txBody>
       </p:sp>
       <p:sp>
         <p:nvSpPr>
@@ -4058,11 +3978,11 @@
           <a:bodyPr wrap="square" lIns="0" tIns="0" rIns="0" bIns="0" rtlCol="0" anchor="ctr"/>
           <a:lstStyle/>
           <a:p>
-            <a:pPr algn="ctr" indent="0" marL="0">
+            <a:pPr marL="0" indent="0" algn="ctr">
               <a:buNone/>
             </a:pPr>
             <a:r>
-              <a:rPr lang="en-US" sz="1000" b="1" spc="100" kern="0" dirty="0">
+              <a:rPr lang="en-US" sz="1000" b="1" kern="0" spc="100" dirty="0">
                 <a:solidFill>
                   <a:srgbClr val="1B5E20"/>
                 </a:solidFill>
@@ -4102,6 +4022,13 @@
             <a:prstDash val="solid"/>
           </a:ln>
         </p:spPr>
+        <p:txBody>
+          <a:bodyPr/>
+          <a:lstStyle/>
+          <a:p>
+            <a:endParaRPr lang="en-IE"/>
+          </a:p>
+        </p:txBody>
       </p:sp>
       <p:sp>
         <p:nvSpPr>
@@ -4124,7 +4051,7 @@
           <a:bodyPr wrap="square" lIns="0" tIns="0" rIns="0" bIns="0" rtlCol="0" anchor="ctr"/>
           <a:lstStyle/>
           <a:p>
-            <a:pPr indent="0" marL="0">
+            <a:pPr marL="0" indent="0">
               <a:buNone/>
             </a:pPr>
             <a:r>
@@ -4290,6 +4217,13 @@
           </a:solidFill>
           <a:ln/>
         </p:spPr>
+        <p:txBody>
+          <a:bodyPr/>
+          <a:lstStyle/>
+          <a:p>
+            <a:endParaRPr lang="en-IE"/>
+          </a:p>
+        </p:txBody>
       </p:sp>
       <p:sp>
         <p:nvSpPr>
@@ -4312,11 +4246,11 @@
           <a:bodyPr wrap="square" lIns="0" tIns="0" rIns="0" bIns="0" rtlCol="0" anchor="ctr"/>
           <a:lstStyle/>
           <a:p>
-            <a:pPr algn="ctr" indent="0" marL="0">
+            <a:pPr marL="0" indent="0" algn="ctr">
               <a:buNone/>
             </a:pPr>
             <a:r>
-              <a:rPr lang="en-US" sz="1000" b="1" spc="100" kern="0" dirty="0">
+              <a:rPr lang="en-US" sz="1000" b="1" kern="0" spc="100" dirty="0">
                 <a:solidFill>
                   <a:srgbClr val="1B5E20"/>
                 </a:solidFill>
@@ -4351,6 +4285,13 @@
           </a:solidFill>
           <a:ln/>
         </p:spPr>
+        <p:txBody>
+          <a:bodyPr/>
+          <a:lstStyle/>
+          <a:p>
+            <a:endParaRPr lang="en-IE"/>
+          </a:p>
+        </p:txBody>
       </p:sp>
       <p:sp>
         <p:nvSpPr>
@@ -4373,11 +4314,11 @@
           <a:bodyPr wrap="square" lIns="0" tIns="0" rIns="0" bIns="0" rtlCol="0" anchor="ctr"/>
           <a:lstStyle/>
           <a:p>
-            <a:pPr algn="ctr" indent="0" marL="0">
+            <a:pPr marL="0" indent="0" algn="ctr">
               <a:buNone/>
             </a:pPr>
             <a:r>
-              <a:rPr lang="en-US" sz="1000" b="1" spc="100" kern="0" dirty="0">
+              <a:rPr lang="en-US" sz="1000" b="1" kern="0" spc="100" dirty="0">
                 <a:solidFill>
                   <a:srgbClr val="1B5E20"/>
                 </a:solidFill>
@@ -4412,6 +4353,13 @@
           </a:solidFill>
           <a:ln/>
         </p:spPr>
+        <p:txBody>
+          <a:bodyPr/>
+          <a:lstStyle/>
+          <a:p>
+            <a:endParaRPr lang="en-IE"/>
+          </a:p>
+        </p:txBody>
       </p:sp>
       <p:sp>
         <p:nvSpPr>
@@ -4434,11 +4382,11 @@
           <a:bodyPr wrap="square" lIns="0" tIns="0" rIns="0" bIns="0" rtlCol="0" anchor="ctr"/>
           <a:lstStyle/>
           <a:p>
-            <a:pPr algn="ctr" indent="0" marL="0">
+            <a:pPr marL="0" indent="0" algn="ctr">
               <a:buNone/>
             </a:pPr>
             <a:r>
-              <a:rPr lang="en-US" sz="1000" b="1" spc="100" kern="0" dirty="0">
+              <a:rPr lang="en-US" sz="1000" b="1" kern="0" spc="100" dirty="0">
                 <a:solidFill>
                   <a:srgbClr val="E65100"/>
                 </a:solidFill>
@@ -4473,7 +4421,7 @@
           <a:bodyPr wrap="square" lIns="0" tIns="0" rIns="0" bIns="0" rtlCol="0" anchor="ctr"/>
           <a:lstStyle/>
           <a:p>
-            <a:pPr algn="ctr" indent="0" marL="0">
+            <a:pPr marL="0" indent="0" algn="ctr">
               <a:buNone/>
             </a:pPr>
             <a:r>
@@ -4507,6 +4455,7 @@
         <a:solidFill>
           <a:srgbClr val="FFFFFF"/>
         </a:solidFill>
+        <a:effectLst/>
       </p:bgPr>
     </p:bg>
     <p:spTree>
@@ -4544,6 +4493,13 @@
           </a:solidFill>
           <a:ln/>
         </p:spPr>
+        <p:txBody>
+          <a:bodyPr/>
+          <a:lstStyle/>
+          <a:p>
+            <a:endParaRPr lang="en-IE"/>
+          </a:p>
+        </p:txBody>
       </p:sp>
       <p:sp>
         <p:nvSpPr>
@@ -4566,11 +4522,11 @@
           <a:bodyPr wrap="square" lIns="0" tIns="0" rIns="0" bIns="0" rtlCol="0" anchor="ctr"/>
           <a:lstStyle/>
           <a:p>
-            <a:pPr algn="ctr" indent="0" marL="0">
+            <a:pPr marL="0" indent="0" algn="ctr">
               <a:buNone/>
             </a:pPr>
             <a:r>
-              <a:rPr lang="en-US" sz="1000" b="1" spc="100" kern="0" dirty="0">
+              <a:rPr lang="en-US" sz="1000" b="1" kern="0" spc="100" dirty="0">
                 <a:solidFill>
                   <a:srgbClr val="FFFFFF"/>
                 </a:solidFill>
@@ -4605,7 +4561,7 @@
           <a:bodyPr wrap="square" lIns="0" tIns="0" rIns="0" bIns="0" rtlCol="0" anchor="ctr"/>
           <a:lstStyle/>
           <a:p>
-            <a:pPr indent="0" marL="0">
+            <a:pPr marL="0" indent="0">
               <a:buNone/>
             </a:pPr>
             <a:r>
@@ -4649,6 +4605,13 @@
             <a:prstDash val="solid"/>
           </a:ln>
         </p:spPr>
+        <p:txBody>
+          <a:bodyPr/>
+          <a:lstStyle/>
+          <a:p>
+            <a:endParaRPr lang="en-IE"/>
+          </a:p>
+        </p:txBody>
       </p:sp>
       <p:sp>
         <p:nvSpPr>
@@ -4669,6 +4632,13 @@
           </a:solidFill>
           <a:ln/>
         </p:spPr>
+        <p:txBody>
+          <a:bodyPr/>
+          <a:lstStyle/>
+          <a:p>
+            <a:endParaRPr lang="en-IE"/>
+          </a:p>
+        </p:txBody>
       </p:sp>
       <p:sp>
         <p:nvSpPr>
@@ -4691,7 +4661,7 @@
           <a:bodyPr wrap="square" lIns="0" tIns="0" rIns="0" bIns="0" rtlCol="0" anchor="ctr"/>
           <a:lstStyle/>
           <a:p>
-            <a:pPr algn="ctr" indent="0" marL="0">
+            <a:pPr marL="0" indent="0" algn="ctr">
               <a:buNone/>
             </a:pPr>
             <a:r>
@@ -4730,7 +4700,7 @@
           <a:bodyPr wrap="square" lIns="0" tIns="0" rIns="0" bIns="0" rtlCol="0" anchor="ctr"/>
           <a:lstStyle/>
           <a:p>
-            <a:pPr indent="0" marL="0">
+            <a:pPr marL="0" indent="0">
               <a:buNone/>
             </a:pPr>
             <a:r>
@@ -4880,6 +4850,13 @@
             <a:prstDash val="solid"/>
           </a:ln>
         </p:spPr>
+        <p:txBody>
+          <a:bodyPr/>
+          <a:lstStyle/>
+          <a:p>
+            <a:endParaRPr lang="en-IE"/>
+          </a:p>
+        </p:txBody>
       </p:sp>
       <p:sp>
         <p:nvSpPr>
@@ -4900,6 +4877,13 @@
           </a:solidFill>
           <a:ln/>
         </p:spPr>
+        <p:txBody>
+          <a:bodyPr/>
+          <a:lstStyle/>
+          <a:p>
+            <a:endParaRPr lang="en-IE"/>
+          </a:p>
+        </p:txBody>
       </p:sp>
       <p:sp>
         <p:nvSpPr>
@@ -4922,7 +4906,7 @@
           <a:bodyPr wrap="square" lIns="0" tIns="0" rIns="0" bIns="0" rtlCol="0" anchor="ctr"/>
           <a:lstStyle/>
           <a:p>
-            <a:pPr algn="ctr" indent="0" marL="0">
+            <a:pPr marL="0" indent="0" algn="ctr">
               <a:buNone/>
             </a:pPr>
             <a:r>
@@ -4961,7 +4945,7 @@
           <a:bodyPr wrap="square" lIns="0" tIns="0" rIns="0" bIns="0" rtlCol="0" anchor="ctr"/>
           <a:lstStyle/>
           <a:p>
-            <a:pPr indent="0" marL="0">
+            <a:pPr marL="0" indent="0">
               <a:buNone/>
             </a:pPr>
             <a:r>
@@ -5090,6 +5074,13 @@
             <a:prstDash val="solid"/>
           </a:ln>
         </p:spPr>
+        <p:txBody>
+          <a:bodyPr/>
+          <a:lstStyle/>
+          <a:p>
+            <a:endParaRPr lang="en-IE"/>
+          </a:p>
+        </p:txBody>
       </p:sp>
       <p:sp>
         <p:nvSpPr>
@@ -5110,6 +5101,13 @@
           </a:solidFill>
           <a:ln/>
         </p:spPr>
+        <p:txBody>
+          <a:bodyPr/>
+          <a:lstStyle/>
+          <a:p>
+            <a:endParaRPr lang="en-IE"/>
+          </a:p>
+        </p:txBody>
       </p:sp>
       <p:sp>
         <p:nvSpPr>
@@ -5132,7 +5130,7 @@
           <a:bodyPr wrap="square" lIns="0" tIns="0" rIns="0" bIns="0" rtlCol="0" anchor="ctr"/>
           <a:lstStyle/>
           <a:p>
-            <a:pPr algn="ctr" indent="0" marL="0">
+            <a:pPr marL="0" indent="0" algn="ctr">
               <a:buNone/>
             </a:pPr>
             <a:r>
@@ -5171,7 +5169,7 @@
           <a:bodyPr wrap="square" lIns="0" tIns="0" rIns="0" bIns="0" rtlCol="0" anchor="ctr"/>
           <a:lstStyle/>
           <a:p>
-            <a:pPr indent="0" marL="0">
+            <a:pPr marL="0" indent="0">
               <a:buNone/>
             </a:pPr>
             <a:r>
@@ -5295,7 +5293,7 @@
           <a:bodyPr wrap="square" lIns="0" tIns="0" rIns="0" bIns="0" rtlCol="0" anchor="ctr"/>
           <a:lstStyle/>
           <a:p>
-            <a:pPr indent="0" marL="0">
+            <a:pPr marL="0" indent="0">
               <a:buNone/>
             </a:pPr>
             <a:r>
@@ -5334,6 +5332,13 @@
           </a:solidFill>
           <a:ln/>
         </p:spPr>
+        <p:txBody>
+          <a:bodyPr/>
+          <a:lstStyle/>
+          <a:p>
+            <a:endParaRPr lang="en-IE"/>
+          </a:p>
+        </p:txBody>
       </p:sp>
       <p:sp>
         <p:nvSpPr>
@@ -5356,11 +5361,11 @@
           <a:bodyPr wrap="square" lIns="0" tIns="0" rIns="0" bIns="0" rtlCol="0" anchor="ctr"/>
           <a:lstStyle/>
           <a:p>
-            <a:pPr algn="ctr" indent="0" marL="0">
+            <a:pPr marL="0" indent="0" algn="ctr">
               <a:buNone/>
             </a:pPr>
             <a:r>
-              <a:rPr lang="en-US" sz="1000" b="1" spc="100" kern="0" dirty="0">
+              <a:rPr lang="en-US" sz="1000" b="1" kern="0" spc="100" dirty="0">
                 <a:solidFill>
                   <a:srgbClr val="26262A"/>
                 </a:solidFill>
@@ -5395,6 +5400,13 @@
           </a:solidFill>
           <a:ln/>
         </p:spPr>
+        <p:txBody>
+          <a:bodyPr/>
+          <a:lstStyle/>
+          <a:p>
+            <a:endParaRPr lang="en-IE"/>
+          </a:p>
+        </p:txBody>
       </p:sp>
       <p:sp>
         <p:nvSpPr>
@@ -5417,11 +5429,11 @@
           <a:bodyPr wrap="square" lIns="0" tIns="0" rIns="0" bIns="0" rtlCol="0" anchor="ctr"/>
           <a:lstStyle/>
           <a:p>
-            <a:pPr algn="ctr" indent="0" marL="0">
+            <a:pPr marL="0" indent="0" algn="ctr">
               <a:buNone/>
             </a:pPr>
             <a:r>
-              <a:rPr lang="en-US" sz="1000" b="1" spc="100" kern="0" dirty="0">
+              <a:rPr lang="en-US" sz="1000" b="1" kern="0" spc="100" dirty="0">
                 <a:solidFill>
                   <a:srgbClr val="26262A"/>
                 </a:solidFill>
@@ -5456,6 +5468,13 @@
           </a:solidFill>
           <a:ln/>
         </p:spPr>
+        <p:txBody>
+          <a:bodyPr/>
+          <a:lstStyle/>
+          <a:p>
+            <a:endParaRPr lang="en-IE"/>
+          </a:p>
+        </p:txBody>
       </p:sp>
       <p:sp>
         <p:nvSpPr>
@@ -5478,11 +5497,11 @@
           <a:bodyPr wrap="square" lIns="0" tIns="0" rIns="0" bIns="0" rtlCol="0" anchor="ctr"/>
           <a:lstStyle/>
           <a:p>
-            <a:pPr algn="ctr" indent="0" marL="0">
+            <a:pPr marL="0" indent="0" algn="ctr">
               <a:buNone/>
             </a:pPr>
             <a:r>
-              <a:rPr lang="en-US" sz="1000" b="1" spc="100" kern="0" dirty="0">
+              <a:rPr lang="en-US" sz="1000" b="1" kern="0" spc="100" dirty="0">
                 <a:solidFill>
                   <a:srgbClr val="26262A"/>
                 </a:solidFill>
@@ -5517,6 +5536,13 @@
           </a:solidFill>
           <a:ln/>
         </p:spPr>
+        <p:txBody>
+          <a:bodyPr/>
+          <a:lstStyle/>
+          <a:p>
+            <a:endParaRPr lang="en-IE"/>
+          </a:p>
+        </p:txBody>
       </p:sp>
       <p:sp>
         <p:nvSpPr>
@@ -5539,11 +5565,11 @@
           <a:bodyPr wrap="square" lIns="0" tIns="0" rIns="0" bIns="0" rtlCol="0" anchor="ctr"/>
           <a:lstStyle/>
           <a:p>
-            <a:pPr algn="ctr" indent="0" marL="0">
+            <a:pPr marL="0" indent="0" algn="ctr">
               <a:buNone/>
             </a:pPr>
             <a:r>
-              <a:rPr lang="en-US" sz="1000" b="1" spc="100" kern="0" dirty="0">
+              <a:rPr lang="en-US" sz="1000" b="1" kern="0" spc="100" dirty="0">
                 <a:solidFill>
                   <a:srgbClr val="26262A"/>
                 </a:solidFill>
@@ -5578,6 +5604,13 @@
           </a:solidFill>
           <a:ln/>
         </p:spPr>
+        <p:txBody>
+          <a:bodyPr/>
+          <a:lstStyle/>
+          <a:p>
+            <a:endParaRPr lang="en-IE"/>
+          </a:p>
+        </p:txBody>
       </p:sp>
       <p:sp>
         <p:nvSpPr>
@@ -5600,11 +5633,11 @@
           <a:bodyPr wrap="square" lIns="0" tIns="0" rIns="0" bIns="0" rtlCol="0" anchor="ctr"/>
           <a:lstStyle/>
           <a:p>
-            <a:pPr algn="ctr" indent="0" marL="0">
+            <a:pPr marL="0" indent="0" algn="ctr">
               <a:buNone/>
             </a:pPr>
             <a:r>
-              <a:rPr lang="en-US" sz="1000" b="1" spc="100" kern="0" dirty="0">
+              <a:rPr lang="en-US" sz="1000" b="1" kern="0" spc="100" dirty="0">
                 <a:solidFill>
                   <a:srgbClr val="26262A"/>
                 </a:solidFill>
@@ -5639,6 +5672,13 @@
           </a:solidFill>
           <a:ln/>
         </p:spPr>
+        <p:txBody>
+          <a:bodyPr/>
+          <a:lstStyle/>
+          <a:p>
+            <a:endParaRPr lang="en-IE"/>
+          </a:p>
+        </p:txBody>
       </p:sp>
       <p:sp>
         <p:nvSpPr>
@@ -5661,11 +5701,11 @@
           <a:bodyPr wrap="square" lIns="0" tIns="0" rIns="0" bIns="0" rtlCol="0" anchor="ctr"/>
           <a:lstStyle/>
           <a:p>
-            <a:pPr algn="ctr" indent="0" marL="0">
+            <a:pPr marL="0" indent="0" algn="ctr">
               <a:buNone/>
             </a:pPr>
             <a:r>
-              <a:rPr lang="en-US" sz="1000" b="1" spc="100" kern="0" dirty="0">
+              <a:rPr lang="en-US" sz="1000" b="1" kern="0" spc="100" dirty="0">
                 <a:solidFill>
                   <a:srgbClr val="26262A"/>
                 </a:solidFill>
@@ -5695,6 +5735,7 @@
         <a:solidFill>
           <a:srgbClr val="FFFFFF"/>
         </a:solidFill>
+        <a:effectLst/>
       </p:bgPr>
     </p:bg>
     <p:spTree>
@@ -5732,6 +5773,13 @@
           </a:solidFill>
           <a:ln/>
         </p:spPr>
+        <p:txBody>
+          <a:bodyPr/>
+          <a:lstStyle/>
+          <a:p>
+            <a:endParaRPr lang="en-IE"/>
+          </a:p>
+        </p:txBody>
       </p:sp>
       <p:sp>
         <p:nvSpPr>
@@ -5754,11 +5802,11 @@
           <a:bodyPr wrap="square" lIns="0" tIns="0" rIns="0" bIns="0" rtlCol="0" anchor="ctr"/>
           <a:lstStyle/>
           <a:p>
-            <a:pPr algn="ctr" indent="0" marL="0">
+            <a:pPr marL="0" indent="0" algn="ctr">
               <a:buNone/>
             </a:pPr>
             <a:r>
-              <a:rPr lang="en-US" sz="1000" b="1" spc="100" kern="0" dirty="0">
+              <a:rPr lang="en-US" sz="1000" b="1" kern="0" spc="100" dirty="0">
                 <a:solidFill>
                   <a:srgbClr val="FFFFFF"/>
                 </a:solidFill>
@@ -5793,7 +5841,7 @@
           <a:bodyPr wrap="square" lIns="0" tIns="0" rIns="0" bIns="0" rtlCol="0" anchor="ctr"/>
           <a:lstStyle/>
           <a:p>
-            <a:pPr indent="0" marL="0">
+            <a:pPr marL="0" indent="0">
               <a:buNone/>
             </a:pPr>
             <a:r>
@@ -5813,14 +5861,14 @@
       </p:sp>
       <p:pic>
         <p:nvPicPr>
-          <p:cNvPr id="5" name="Image 0" descr="C:/Users/phoga/OneDrive/Documents/GitHub/peppard-ipas/docs/screens/00-splash.png">    </p:cNvPr>
+          <p:cNvPr id="5" name="Image 0" descr="C:/Users/phoga/OneDrive/Documents/GitHub/peppard-ipas/docs/screens/00-splash.png"/>
           <p:cNvPicPr>
             <a:picLocks noChangeAspect="1"/>
           </p:cNvPicPr>
           <p:nvPr/>
         </p:nvPicPr>
         <p:blipFill>
-          <a:blip r:embed="rId1"/>
+          <a:blip r:embed="rId3"/>
           <a:stretch>
             <a:fillRect/>
           </a:stretch>
@@ -5861,6 +5909,13 @@
             <a:prstDash val="solid"/>
           </a:ln>
         </p:spPr>
+        <p:txBody>
+          <a:bodyPr/>
+          <a:lstStyle/>
+          <a:p>
+            <a:endParaRPr lang="en-IE"/>
+          </a:p>
+        </p:txBody>
       </p:sp>
       <p:sp>
         <p:nvSpPr>
@@ -5984,6 +6039,7 @@
         <a:solidFill>
           <a:srgbClr val="FFFFFF"/>
         </a:solidFill>
+        <a:effectLst/>
       </p:bgPr>
     </p:bg>
     <p:spTree>
@@ -6021,6 +6077,13 @@
           </a:solidFill>
           <a:ln/>
         </p:spPr>
+        <p:txBody>
+          <a:bodyPr/>
+          <a:lstStyle/>
+          <a:p>
+            <a:endParaRPr lang="en-IE"/>
+          </a:p>
+        </p:txBody>
       </p:sp>
       <p:sp>
         <p:nvSpPr>
@@ -6043,11 +6106,11 @@
           <a:bodyPr wrap="square" lIns="0" tIns="0" rIns="0" bIns="0" rtlCol="0" anchor="ctr"/>
           <a:lstStyle/>
           <a:p>
-            <a:pPr algn="ctr" indent="0" marL="0">
+            <a:pPr marL="0" indent="0" algn="ctr">
               <a:buNone/>
             </a:pPr>
             <a:r>
-              <a:rPr lang="en-US" sz="1000" b="1" spc="100" kern="0" dirty="0">
+              <a:rPr lang="en-US" sz="1000" b="1" kern="0" spc="100" dirty="0">
                 <a:solidFill>
                   <a:srgbClr val="FFFFFF"/>
                 </a:solidFill>
@@ -6082,7 +6145,7 @@
           <a:bodyPr wrap="square" lIns="0" tIns="0" rIns="0" bIns="0" rtlCol="0" anchor="ctr"/>
           <a:lstStyle/>
           <a:p>
-            <a:pPr indent="0" marL="0">
+            <a:pPr marL="0" indent="0">
               <a:buNone/>
             </a:pPr>
             <a:r>
@@ -6102,14 +6165,14 @@
       </p:sp>
       <p:pic>
         <p:nvPicPr>
-          <p:cNvPr id="5" name="Image 0" descr="C:/Users/phoga/OneDrive/Documents/GitHub/peppard-ipas/docs/screens/01-group-overview.png">    </p:cNvPr>
+          <p:cNvPr id="5" name="Image 0" descr="C:/Users/phoga/OneDrive/Documents/GitHub/peppard-ipas/docs/screens/01-group-overview.png"/>
           <p:cNvPicPr>
             <a:picLocks noChangeAspect="1"/>
           </p:cNvPicPr>
           <p:nvPr/>
         </p:nvPicPr>
         <p:blipFill>
-          <a:blip r:embed="rId1"/>
+          <a:blip r:embed="rId3"/>
           <a:stretch>
             <a:fillRect/>
           </a:stretch>
@@ -6150,6 +6213,13 @@
             <a:prstDash val="solid"/>
           </a:ln>
         </p:spPr>
+        <p:txBody>
+          <a:bodyPr/>
+          <a:lstStyle/>
+          <a:p>
+            <a:endParaRPr lang="en-IE"/>
+          </a:p>
+        </p:txBody>
       </p:sp>
       <p:sp>
         <p:nvSpPr>
@@ -6294,6 +6364,7 @@
         <a:solidFill>
           <a:srgbClr val="FFFFFF"/>
         </a:solidFill>
+        <a:effectLst/>
       </p:bgPr>
     </p:bg>
     <p:spTree>
@@ -6331,6 +6402,13 @@
           </a:solidFill>
           <a:ln/>
         </p:spPr>
+        <p:txBody>
+          <a:bodyPr/>
+          <a:lstStyle/>
+          <a:p>
+            <a:endParaRPr lang="en-IE"/>
+          </a:p>
+        </p:txBody>
       </p:sp>
       <p:sp>
         <p:nvSpPr>
@@ -6353,11 +6431,11 @@
           <a:bodyPr wrap="square" lIns="0" tIns="0" rIns="0" bIns="0" rtlCol="0" anchor="ctr"/>
           <a:lstStyle/>
           <a:p>
-            <a:pPr algn="ctr" indent="0" marL="0">
+            <a:pPr marL="0" indent="0" algn="ctr">
               <a:buNone/>
             </a:pPr>
             <a:r>
-              <a:rPr lang="en-US" sz="1000" b="1" spc="100" kern="0" dirty="0">
+              <a:rPr lang="en-US" sz="1000" b="1" kern="0" spc="100" dirty="0">
                 <a:solidFill>
                   <a:srgbClr val="FFFFFF"/>
                 </a:solidFill>
@@ -6392,7 +6470,7 @@
           <a:bodyPr wrap="square" lIns="0" tIns="0" rIns="0" bIns="0" rtlCol="0" anchor="ctr"/>
           <a:lstStyle/>
           <a:p>
-            <a:pPr indent="0" marL="0">
+            <a:pPr marL="0" indent="0">
               <a:buNone/>
             </a:pPr>
             <a:r>
@@ -6412,14 +6490,14 @@
       </p:sp>
       <p:pic>
         <p:nvPicPr>
-          <p:cNvPr id="5" name="Image 0" descr="C:/Users/phoga/OneDrive/Documents/GitHub/peppard-ipas/docs/screens/02-centre-operations.png">    </p:cNvPr>
+          <p:cNvPr id="5" name="Image 0" descr="C:/Users/phoga/OneDrive/Documents/GitHub/peppard-ipas/docs/screens/02-centre-operations.png"/>
           <p:cNvPicPr>
             <a:picLocks noChangeAspect="1"/>
           </p:cNvPicPr>
           <p:nvPr/>
         </p:nvPicPr>
         <p:blipFill>
-          <a:blip r:embed="rId1"/>
+          <a:blip r:embed="rId3"/>
           <a:stretch>
             <a:fillRect/>
           </a:stretch>
@@ -6460,6 +6538,13 @@
             <a:prstDash val="solid"/>
           </a:ln>
         </p:spPr>
+        <p:txBody>
+          <a:bodyPr/>
+          <a:lstStyle/>
+          <a:p>
+            <a:endParaRPr lang="en-IE"/>
+          </a:p>
+        </p:txBody>
       </p:sp>
       <p:sp>
         <p:nvSpPr>
@@ -6583,6 +6668,7 @@
         <a:solidFill>
           <a:srgbClr val="FFFFFF"/>
         </a:solidFill>
+        <a:effectLst/>
       </p:bgPr>
     </p:bg>
     <p:spTree>
@@ -6620,6 +6706,13 @@
           </a:solidFill>
           <a:ln/>
         </p:spPr>
+        <p:txBody>
+          <a:bodyPr/>
+          <a:lstStyle/>
+          <a:p>
+            <a:endParaRPr lang="en-IE"/>
+          </a:p>
+        </p:txBody>
       </p:sp>
       <p:sp>
         <p:nvSpPr>
@@ -6642,11 +6735,11 @@
           <a:bodyPr wrap="square" lIns="0" tIns="0" rIns="0" bIns="0" rtlCol="0" anchor="ctr"/>
           <a:lstStyle/>
           <a:p>
-            <a:pPr algn="ctr" indent="0" marL="0">
+            <a:pPr marL="0" indent="0" algn="ctr">
               <a:buNone/>
             </a:pPr>
             <a:r>
-              <a:rPr lang="en-US" sz="1000" b="1" spc="100" kern="0" dirty="0">
+              <a:rPr lang="en-US" sz="1000" b="1" kern="0" spc="100" dirty="0">
                 <a:solidFill>
                   <a:srgbClr val="FFFFFF"/>
                 </a:solidFill>
@@ -6681,7 +6774,7 @@
           <a:bodyPr wrap="square" lIns="0" tIns="0" rIns="0" bIns="0" rtlCol="0" anchor="ctr"/>
           <a:lstStyle/>
           <a:p>
-            <a:pPr indent="0" marL="0">
+            <a:pPr marL="0" indent="0">
               <a:buNone/>
             </a:pPr>
             <a:r>
@@ -6701,14 +6794,14 @@
       </p:sp>
       <p:pic>
         <p:nvPicPr>
-          <p:cNvPr id="5" name="Image 0" descr="C:/Users/phoga/OneDrive/Documents/GitHub/peppard-ipas/docs/screens/03-findings-tracker.png">    </p:cNvPr>
+          <p:cNvPr id="5" name="Image 0" descr="C:/Users/phoga/OneDrive/Documents/GitHub/peppard-ipas/docs/screens/03-findings-tracker.png"/>
           <p:cNvPicPr>
             <a:picLocks noChangeAspect="1"/>
           </p:cNvPicPr>
           <p:nvPr/>
         </p:nvPicPr>
         <p:blipFill>
-          <a:blip r:embed="rId1"/>
+          <a:blip r:embed="rId3"/>
           <a:stretch>
             <a:fillRect/>
           </a:stretch>
@@ -6749,6 +6842,13 @@
             <a:prstDash val="solid"/>
           </a:ln>
         </p:spPr>
+        <p:txBody>
+          <a:bodyPr/>
+          <a:lstStyle/>
+          <a:p>
+            <a:endParaRPr lang="en-IE"/>
+          </a:p>
+        </p:txBody>
       </p:sp>
       <p:sp>
         <p:nvSpPr>
@@ -6872,6 +6972,7 @@
         <a:solidFill>
           <a:srgbClr val="FFFFFF"/>
         </a:solidFill>
+        <a:effectLst/>
       </p:bgPr>
     </p:bg>
     <p:spTree>
@@ -6909,6 +7010,13 @@
           </a:solidFill>
           <a:ln/>
         </p:spPr>
+        <p:txBody>
+          <a:bodyPr/>
+          <a:lstStyle/>
+          <a:p>
+            <a:endParaRPr lang="en-IE"/>
+          </a:p>
+        </p:txBody>
       </p:sp>
       <p:sp>
         <p:nvSpPr>
@@ -6931,11 +7039,11 @@
           <a:bodyPr wrap="square" lIns="0" tIns="0" rIns="0" bIns="0" rtlCol="0" anchor="ctr"/>
           <a:lstStyle/>
           <a:p>
-            <a:pPr algn="ctr" indent="0" marL="0">
+            <a:pPr marL="0" indent="0" algn="ctr">
               <a:buNone/>
             </a:pPr>
             <a:r>
-              <a:rPr lang="en-US" sz="1000" b="1" spc="100" kern="0" dirty="0">
+              <a:rPr lang="en-US" sz="1000" b="1" kern="0" spc="100" dirty="0">
                 <a:solidFill>
                   <a:srgbClr val="FFFFFF"/>
                 </a:solidFill>
@@ -6970,7 +7078,7 @@
           <a:bodyPr wrap="square" lIns="0" tIns="0" rIns="0" bIns="0" rtlCol="0" anchor="ctr"/>
           <a:lstStyle/>
           <a:p>
-            <a:pPr indent="0" marL="0">
+            <a:pPr marL="0" indent="0">
               <a:buNone/>
             </a:pPr>
             <a:r>
@@ -6990,14 +7098,14 @@
       </p:sp>
       <p:pic>
         <p:nvPicPr>
-          <p:cNvPr id="5" name="Image 0" descr="C:/Users/phoga/OneDrive/Documents/GitHub/peppard-ipas/docs/screens/04-standards-register.png">    </p:cNvPr>
+          <p:cNvPr id="5" name="Image 0" descr="C:/Users/phoga/OneDrive/Documents/GitHub/peppard-ipas/docs/screens/04-standards-register.png"/>
           <p:cNvPicPr>
             <a:picLocks noChangeAspect="1"/>
           </p:cNvPicPr>
           <p:nvPr/>
         </p:nvPicPr>
         <p:blipFill>
-          <a:blip r:embed="rId1"/>
+          <a:blip r:embed="rId3"/>
           <a:stretch>
             <a:fillRect/>
           </a:stretch>
@@ -7038,6 +7146,13 @@
             <a:prstDash val="solid"/>
           </a:ln>
         </p:spPr>
+        <p:txBody>
+          <a:bodyPr/>
+          <a:lstStyle/>
+          <a:p>
+            <a:endParaRPr lang="en-IE"/>
+          </a:p>
+        </p:txBody>
       </p:sp>
       <p:sp>
         <p:nvSpPr>
@@ -7161,6 +7276,7 @@
         <a:solidFill>
           <a:srgbClr val="FFFFFF"/>
         </a:solidFill>
+        <a:effectLst/>
       </p:bgPr>
     </p:bg>
     <p:spTree>
@@ -7198,6 +7314,13 @@
           </a:solidFill>
           <a:ln/>
         </p:spPr>
+        <p:txBody>
+          <a:bodyPr/>
+          <a:lstStyle/>
+          <a:p>
+            <a:endParaRPr lang="en-IE"/>
+          </a:p>
+        </p:txBody>
       </p:sp>
       <p:sp>
         <p:nvSpPr>
@@ -7220,11 +7343,11 @@
           <a:bodyPr wrap="square" lIns="0" tIns="0" rIns="0" bIns="0" rtlCol="0" anchor="ctr"/>
           <a:lstStyle/>
           <a:p>
-            <a:pPr algn="ctr" indent="0" marL="0">
+            <a:pPr marL="0" indent="0" algn="ctr">
               <a:buNone/>
             </a:pPr>
             <a:r>
-              <a:rPr lang="en-US" sz="1000" b="1" spc="100" kern="0" dirty="0">
+              <a:rPr lang="en-US" sz="1000" b="1" kern="0" spc="100" dirty="0">
                 <a:solidFill>
                   <a:srgbClr val="FFFFFF"/>
                 </a:solidFill>
@@ -7259,7 +7382,7 @@
           <a:bodyPr wrap="square" lIns="0" tIns="0" rIns="0" bIns="0" rtlCol="0" anchor="ctr"/>
           <a:lstStyle/>
           <a:p>
-            <a:pPr indent="0" marL="0">
+            <a:pPr marL="0" indent="0">
               <a:buNone/>
             </a:pPr>
             <a:r>
@@ -7279,14 +7402,14 @@
       </p:sp>
       <p:pic>
         <p:nvPicPr>
-          <p:cNvPr id="5" name="Image 0" descr="C:/Users/phoga/OneDrive/Documents/GitHub/peppard-ipas/docs/screens/05-kpi-framework.png">    </p:cNvPr>
+          <p:cNvPr id="5" name="Image 0" descr="C:/Users/phoga/OneDrive/Documents/GitHub/peppard-ipas/docs/screens/05-kpi-framework.png"/>
           <p:cNvPicPr>
             <a:picLocks noChangeAspect="1"/>
           </p:cNvPicPr>
           <p:nvPr/>
         </p:nvPicPr>
         <p:blipFill>
-          <a:blip r:embed="rId1"/>
+          <a:blip r:embed="rId3"/>
           <a:stretch>
             <a:fillRect/>
           </a:stretch>
@@ -7327,6 +7450,13 @@
             <a:prstDash val="solid"/>
           </a:ln>
         </p:spPr>
+        <p:txBody>
+          <a:bodyPr/>
+          <a:lstStyle/>
+          <a:p>
+            <a:endParaRPr lang="en-IE"/>
+          </a:p>
+        </p:txBody>
       </p:sp>
       <p:sp>
         <p:nvSpPr>
@@ -7735,4 +7865,319 @@
     </a:ext>
   </a:extLst>
 </a:theme>
+</file>
+
+<file path=ppt/theme/theme2.xml><?xml version="1.0" encoding="utf-8"?>
+<a:theme xmlns:a="http://schemas.openxmlformats.org/drawingml/2006/main" name="Office Theme">
+  <a:themeElements>
+    <a:clrScheme name="Office">
+      <a:dk1>
+        <a:sysClr val="windowText" lastClr="000000"/>
+      </a:dk1>
+      <a:lt1>
+        <a:sysClr val="window" lastClr="FFFFFF"/>
+      </a:lt1>
+      <a:dk2>
+        <a:srgbClr val="0E2841"/>
+      </a:dk2>
+      <a:lt2>
+        <a:srgbClr val="E8E8E8"/>
+      </a:lt2>
+      <a:accent1>
+        <a:srgbClr val="156082"/>
+      </a:accent1>
+      <a:accent2>
+        <a:srgbClr val="E97132"/>
+      </a:accent2>
+      <a:accent3>
+        <a:srgbClr val="196B24"/>
+      </a:accent3>
+      <a:accent4>
+        <a:srgbClr val="0F9ED5"/>
+      </a:accent4>
+      <a:accent5>
+        <a:srgbClr val="A02B93"/>
+      </a:accent5>
+      <a:accent6>
+        <a:srgbClr val="4EA72E"/>
+      </a:accent6>
+      <a:hlink>
+        <a:srgbClr val="467886"/>
+      </a:hlink>
+      <a:folHlink>
+        <a:srgbClr val="96607D"/>
+      </a:folHlink>
+    </a:clrScheme>
+    <a:fontScheme name="Office">
+      <a:majorFont>
+        <a:latin typeface="Aptos Display" panose="02110004020202020204"/>
+        <a:ea typeface=""/>
+        <a:cs typeface=""/>
+        <a:font script="Jpan" typeface="游ゴシック Light"/>
+        <a:font script="Hang" typeface="맑은 고딕"/>
+        <a:font script="Hans" typeface="等线 Light"/>
+        <a:font script="Hant" typeface="新細明體"/>
+        <a:font script="Arab" typeface="Times New Roman"/>
+        <a:font script="Hebr" typeface="Times New Roman"/>
+        <a:font script="Thai" typeface="Angsana New"/>
+        <a:font script="Ethi" typeface="Nyala"/>
+        <a:font script="Beng" typeface="Vrinda"/>
+        <a:font script="Gujr" typeface="Shruti"/>
+        <a:font script="Khmr" typeface="MoolBoran"/>
+        <a:font script="Knda" typeface="Tunga"/>
+        <a:font script="Guru" typeface="Raavi"/>
+        <a:font script="Cans" typeface="Euphemia"/>
+        <a:font script="Cher" typeface="Plantagenet Cherokee"/>
+        <a:font script="Yiii" typeface="Microsoft Yi Baiti"/>
+        <a:font script="Tibt" typeface="Microsoft Himalaya"/>
+        <a:font script="Thaa" typeface="MV Boli"/>
+        <a:font script="Deva" typeface="Mangal"/>
+        <a:font script="Telu" typeface="Gautami"/>
+        <a:font script="Taml" typeface="Latha"/>
+        <a:font script="Syrc" typeface="Estrangelo Edessa"/>
+        <a:font script="Orya" typeface="Kalinga"/>
+        <a:font script="Mlym" typeface="Kartika"/>
+        <a:font script="Laoo" typeface="DokChampa"/>
+        <a:font script="Sinh" typeface="Iskoola Pota"/>
+        <a:font script="Mong" typeface="Mongolian Baiti"/>
+        <a:font script="Viet" typeface="Times New Roman"/>
+        <a:font script="Uigh" typeface="Microsoft Uighur"/>
+        <a:font script="Geor" typeface="Sylfaen"/>
+        <a:font script="Armn" typeface="Arial"/>
+        <a:font script="Bugi" typeface="Leelawadee UI"/>
+        <a:font script="Bopo" typeface="Microsoft JhengHei"/>
+        <a:font script="Java" typeface="Javanese Text"/>
+        <a:font script="Lisu" typeface="Segoe UI"/>
+        <a:font script="Mymr" typeface="Myanmar Text"/>
+        <a:font script="Nkoo" typeface="Ebrima"/>
+        <a:font script="Olck" typeface="Nirmala UI"/>
+        <a:font script="Osma" typeface="Ebrima"/>
+        <a:font script="Phag" typeface="Phagspa"/>
+        <a:font script="Syrn" typeface="Estrangelo Edessa"/>
+        <a:font script="Syrj" typeface="Estrangelo Edessa"/>
+        <a:font script="Syre" typeface="Estrangelo Edessa"/>
+        <a:font script="Sora" typeface="Nirmala UI"/>
+        <a:font script="Tale" typeface="Microsoft Tai Le"/>
+        <a:font script="Talu" typeface="Microsoft New Tai Lue"/>
+        <a:font script="Tfng" typeface="Ebrima"/>
+      </a:majorFont>
+      <a:minorFont>
+        <a:latin typeface="Aptos" panose="02110004020202020204"/>
+        <a:ea typeface=""/>
+        <a:cs typeface=""/>
+        <a:font script="Jpan" typeface="游ゴシック"/>
+        <a:font script="Hang" typeface="맑은 고딕"/>
+        <a:font script="Hans" typeface="等线"/>
+        <a:font script="Hant" typeface="新細明體"/>
+        <a:font script="Arab" typeface="Arial"/>
+        <a:font script="Hebr" typeface="Arial"/>
+        <a:font script="Thai" typeface="Cordia New"/>
+        <a:font script="Ethi" typeface="Nyala"/>
+        <a:font script="Beng" typeface="Vrinda"/>
+        <a:font script="Gujr" typeface="Shruti"/>
+        <a:font script="Khmr" typeface="DaunPenh"/>
+        <a:font script="Knda" typeface="Tunga"/>
+        <a:font script="Guru" typeface="Raavi"/>
+        <a:font script="Cans" typeface="Euphemia"/>
+        <a:font script="Cher" typeface="Plantagenet Cherokee"/>
+        <a:font script="Yiii" typeface="Microsoft Yi Baiti"/>
+        <a:font script="Tibt" typeface="Microsoft Himalaya"/>
+        <a:font script="Thaa" typeface="MV Boli"/>
+        <a:font script="Deva" typeface="Mangal"/>
+        <a:font script="Telu" typeface="Gautami"/>
+        <a:font script="Taml" typeface="Latha"/>
+        <a:font script="Syrc" typeface="Estrangelo Edessa"/>
+        <a:font script="Orya" typeface="Kalinga"/>
+        <a:font script="Mlym" typeface="Kartika"/>
+        <a:font script="Laoo" typeface="DokChampa"/>
+        <a:font script="Sinh" typeface="Iskoola Pota"/>
+        <a:font script="Mong" typeface="Mongolian Baiti"/>
+        <a:font script="Viet" typeface="Arial"/>
+        <a:font script="Uigh" typeface="Microsoft Uighur"/>
+        <a:font script="Geor" typeface="Sylfaen"/>
+        <a:font script="Armn" typeface="Arial"/>
+        <a:font script="Bugi" typeface="Leelawadee UI"/>
+        <a:font script="Bopo" typeface="Microsoft JhengHei"/>
+        <a:font script="Java" typeface="Javanese Text"/>
+        <a:font script="Lisu" typeface="Segoe UI"/>
+        <a:font script="Mymr" typeface="Myanmar Text"/>
+        <a:font script="Nkoo" typeface="Ebrima"/>
+        <a:font script="Olck" typeface="Nirmala UI"/>
+        <a:font script="Osma" typeface="Ebrima"/>
+        <a:font script="Phag" typeface="Phagspa"/>
+        <a:font script="Syrn" typeface="Estrangelo Edessa"/>
+        <a:font script="Syrj" typeface="Estrangelo Edessa"/>
+        <a:font script="Syre" typeface="Estrangelo Edessa"/>
+        <a:font script="Sora" typeface="Nirmala UI"/>
+        <a:font script="Tale" typeface="Microsoft Tai Le"/>
+        <a:font script="Talu" typeface="Microsoft New Tai Lue"/>
+        <a:font script="Tfng" typeface="Ebrima"/>
+      </a:minorFont>
+    </a:fontScheme>
+    <a:fmtScheme name="Office">
+      <a:fillStyleLst>
+        <a:solidFill>
+          <a:schemeClr val="phClr"/>
+        </a:solidFill>
+        <a:gradFill rotWithShape="1">
+          <a:gsLst>
+            <a:gs pos="0">
+              <a:schemeClr val="phClr">
+                <a:lumMod val="110000"/>
+                <a:satMod val="105000"/>
+                <a:tint val="67000"/>
+              </a:schemeClr>
+            </a:gs>
+            <a:gs pos="50000">
+              <a:schemeClr val="phClr">
+                <a:lumMod val="105000"/>
+                <a:satMod val="103000"/>
+                <a:tint val="73000"/>
+              </a:schemeClr>
+            </a:gs>
+            <a:gs pos="100000">
+              <a:schemeClr val="phClr">
+                <a:lumMod val="105000"/>
+                <a:satMod val="109000"/>
+                <a:tint val="81000"/>
+              </a:schemeClr>
+            </a:gs>
+          </a:gsLst>
+          <a:lin ang="5400000" scaled="0"/>
+        </a:gradFill>
+        <a:gradFill rotWithShape="1">
+          <a:gsLst>
+            <a:gs pos="0">
+              <a:schemeClr val="phClr">
+                <a:satMod val="103000"/>
+                <a:lumMod val="102000"/>
+                <a:tint val="94000"/>
+              </a:schemeClr>
+            </a:gs>
+            <a:gs pos="50000">
+              <a:schemeClr val="phClr">
+                <a:satMod val="110000"/>
+                <a:lumMod val="100000"/>
+                <a:shade val="100000"/>
+              </a:schemeClr>
+            </a:gs>
+            <a:gs pos="100000">
+              <a:schemeClr val="phClr">
+                <a:lumMod val="99000"/>
+                <a:satMod val="120000"/>
+                <a:shade val="78000"/>
+              </a:schemeClr>
+            </a:gs>
+          </a:gsLst>
+          <a:lin ang="5400000" scaled="0"/>
+        </a:gradFill>
+      </a:fillStyleLst>
+      <a:lnStyleLst>
+        <a:ln w="12700" cap="flat" cmpd="sng" algn="ctr">
+          <a:solidFill>
+            <a:schemeClr val="phClr"/>
+          </a:solidFill>
+          <a:prstDash val="solid"/>
+          <a:miter lim="800000"/>
+        </a:ln>
+        <a:ln w="19050" cap="flat" cmpd="sng" algn="ctr">
+          <a:solidFill>
+            <a:schemeClr val="phClr"/>
+          </a:solidFill>
+          <a:prstDash val="solid"/>
+          <a:miter lim="800000"/>
+        </a:ln>
+        <a:ln w="25400" cap="flat" cmpd="sng" algn="ctr">
+          <a:solidFill>
+            <a:schemeClr val="phClr"/>
+          </a:solidFill>
+          <a:prstDash val="solid"/>
+          <a:miter lim="800000"/>
+        </a:ln>
+      </a:lnStyleLst>
+      <a:effectStyleLst>
+        <a:effectStyle>
+          <a:effectLst/>
+        </a:effectStyle>
+        <a:effectStyle>
+          <a:effectLst/>
+        </a:effectStyle>
+        <a:effectStyle>
+          <a:effectLst>
+            <a:outerShdw blurRad="57150" dist="19050" dir="5400000" algn="ctr" rotWithShape="0">
+              <a:srgbClr val="000000">
+                <a:alpha val="63000"/>
+              </a:srgbClr>
+            </a:outerShdw>
+          </a:effectLst>
+        </a:effectStyle>
+      </a:effectStyleLst>
+      <a:bgFillStyleLst>
+        <a:solidFill>
+          <a:schemeClr val="phClr"/>
+        </a:solidFill>
+        <a:solidFill>
+          <a:schemeClr val="phClr">
+            <a:tint val="95000"/>
+            <a:satMod val="170000"/>
+          </a:schemeClr>
+        </a:solidFill>
+        <a:gradFill rotWithShape="1">
+          <a:gsLst>
+            <a:gs pos="0">
+              <a:schemeClr val="phClr">
+                <a:tint val="93000"/>
+                <a:satMod val="150000"/>
+                <a:shade val="98000"/>
+                <a:lumMod val="102000"/>
+              </a:schemeClr>
+            </a:gs>
+            <a:gs pos="50000">
+              <a:schemeClr val="phClr">
+                <a:tint val="98000"/>
+                <a:satMod val="130000"/>
+                <a:shade val="90000"/>
+                <a:lumMod val="103000"/>
+              </a:schemeClr>
+            </a:gs>
+            <a:gs pos="100000">
+              <a:schemeClr val="phClr">
+                <a:shade val="63000"/>
+                <a:satMod val="120000"/>
+              </a:schemeClr>
+            </a:gs>
+          </a:gsLst>
+          <a:lin ang="5400000" scaled="0"/>
+        </a:gradFill>
+      </a:bgFillStyleLst>
+    </a:fmtScheme>
+  </a:themeElements>
+  <a:objectDefaults>
+    <a:lnDef>
+      <a:spPr/>
+      <a:bodyPr/>
+      <a:lstStyle/>
+      <a:style>
+        <a:lnRef idx="2">
+          <a:schemeClr val="accent1"/>
+        </a:lnRef>
+        <a:fillRef idx="0">
+          <a:schemeClr val="accent1"/>
+        </a:fillRef>
+        <a:effectRef idx="1">
+          <a:schemeClr val="accent1"/>
+        </a:effectRef>
+        <a:fontRef idx="minor">
+          <a:schemeClr val="tx1"/>
+        </a:fontRef>
+      </a:style>
+    </a:lnDef>
+  </a:objectDefaults>
+  <a:extraClrSchemeLst/>
+  <a:extLst>
+    <a:ext uri="{05A4C25C-085E-4340-85A3-A5531E510DB2}">
+      <thm15:themeFamily xmlns:thm15="http://schemas.microsoft.com/office/thememl/2012/main" name="Office Theme" id="{2E142A2C-CD16-42D6-873A-C26D2A0506FA}" vid="{1BDDFF52-6CD6-40A5-AB3C-68EB2F1E4D0A}"/>
+    </a:ext>
+  </a:extLst>
+</a:theme>
 </file>
</xml_diff>